<commit_message>
Add data privacy slide to report deck
</commit_message>
<xml_diff>
--- a/IvyEuro_Education_网站改造分析报告.pptx
+++ b/IvyEuro_Education_网站改造分析报告.pptx
@@ -13,6 +13,7 @@
     <p:sldId id="261" r:id="rId12"/>
     <p:sldId id="262" r:id="rId13"/>
     <p:sldId id="263" r:id="rId14"/>
+    <p:sldId id="264" r:id="rId15"/>
   </p:sldIdLst>
   <p:sldSz cx="12191695" cy="6858000" type="screen4x3"/>
   <p:notesSz cx="6858000" cy="9144000"/>
@@ -9235,6 +9236,1030 @@
 </file>
 
 <file path=ppt/slides/slide8.xml><?xml version="1.0" encoding="utf-8"?>
+<p:sld xmlns:a="http://schemas.openxmlformats.org/drawingml/2006/main" xmlns:p="http://schemas.openxmlformats.org/presentationml/2006/main" xmlns:r="http://schemas.openxmlformats.org/officeDocument/2006/relationships">
+  <p:cSld>
+    <p:bg>
+      <p:bgPr>
+        <a:solidFill>
+          <a:srgbClr val="FFFFFF"/>
+        </a:solidFill>
+        <a:effectLst/>
+      </p:bgPr>
+    </p:bg>
+    <p:spTree>
+      <p:nvGrpSpPr>
+        <p:cNvPr id="1" name=""/>
+        <p:cNvGrpSpPr/>
+        <p:nvPr/>
+      </p:nvGrpSpPr>
+      <p:grpSpPr/>
+      <p:sp>
+        <p:nvSpPr>
+          <p:cNvPr id="2" name="Rectangle 1"/>
+          <p:cNvSpPr/>
+          <p:nvPr/>
+        </p:nvSpPr>
+        <p:spPr>
+          <a:xfrm>
+            <a:off x="0" y="0"/>
+            <a:ext cx="12191695" cy="841248"/>
+          </a:xfrm>
+          <a:prstGeom prst="rect">
+            <a:avLst/>
+          </a:prstGeom>
+          <a:solidFill>
+            <a:srgbClr val="0B1220"/>
+          </a:solidFill>
+          <a:ln>
+            <a:noFill/>
+          </a:ln>
+        </p:spPr>
+        <p:style>
+          <a:lnRef idx="1">
+            <a:schemeClr val="accent1"/>
+          </a:lnRef>
+          <a:fillRef idx="3">
+            <a:schemeClr val="accent1"/>
+          </a:fillRef>
+          <a:effectRef idx="2">
+            <a:schemeClr val="accent1"/>
+          </a:effectRef>
+          <a:fontRef idx="minor">
+            <a:schemeClr val="lt1"/>
+          </a:fontRef>
+        </p:style>
+        <p:txBody>
+          <a:bodyPr rtlCol="0" anchor="ctr"/>
+          <a:lstStyle/>
+          <a:p>
+            <a:pPr algn="ctr"/>
+          </a:p>
+        </p:txBody>
+      </p:sp>
+      <p:sp>
+        <p:nvSpPr>
+          <p:cNvPr id="3" name="TextBox 2"/>
+          <p:cNvSpPr txBox="1"/>
+          <p:nvPr/>
+        </p:nvSpPr>
+        <p:spPr>
+          <a:xfrm>
+            <a:off x="502920" y="164592"/>
+            <a:ext cx="9692640" cy="384048"/>
+          </a:xfrm>
+          <a:prstGeom prst="rect">
+            <a:avLst/>
+          </a:prstGeom>
+          <a:noFill/>
+        </p:spPr>
+        <p:txBody>
+          <a:bodyPr wrap="none">
+            <a:spAutoFit/>
+          </a:bodyPr>
+          <a:lstStyle/>
+          <a:p>
+            <a:r>
+              <a:rPr sz="2000" b="1">
+                <a:solidFill>
+                  <a:srgbClr val="FFFFFF"/>
+                </a:solidFill>
+                <a:latin typeface="Microsoft YaHei"/>
+              </a:rPr>
+              <a:t>微信数据模板</a:t>
+            </a:r>
+          </a:p>
+        </p:txBody>
+      </p:sp>
+      <p:sp>
+        <p:nvSpPr>
+          <p:cNvPr id="4" name="TextBox 3"/>
+          <p:cNvSpPr txBox="1"/>
+          <p:nvPr/>
+        </p:nvSpPr>
+        <p:spPr>
+          <a:xfrm>
+            <a:off x="8412480" y="182880"/>
+            <a:ext cx="3291840" cy="310896"/>
+          </a:xfrm>
+          <a:prstGeom prst="rect">
+            <a:avLst/>
+          </a:prstGeom>
+          <a:noFill/>
+        </p:spPr>
+        <p:txBody>
+          <a:bodyPr wrap="none">
+            <a:spAutoFit/>
+          </a:bodyPr>
+          <a:lstStyle/>
+          <a:p>
+            <a:pPr algn="r"/>
+            <a:r>
+              <a:rPr sz="1050">
+                <a:solidFill>
+                  <a:srgbClr val="CCD6E0"/>
+                </a:solidFill>
+                <a:latin typeface="Microsoft YaHei"/>
+              </a:rPr>
+              <a:t>只记业务字段，不存完整聊天</a:t>
+            </a:r>
+          </a:p>
+        </p:txBody>
+      </p:sp>
+      <p:sp>
+        <p:nvSpPr>
+          <p:cNvPr id="5" name="TextBox 4"/>
+          <p:cNvSpPr txBox="1"/>
+          <p:nvPr/>
+        </p:nvSpPr>
+        <p:spPr>
+          <a:xfrm>
+            <a:off x="594360" y="1051560"/>
+            <a:ext cx="10789920" cy="1280160"/>
+          </a:xfrm>
+          <a:prstGeom prst="rect">
+            <a:avLst/>
+          </a:prstGeom>
+          <a:noFill/>
+        </p:spPr>
+        <p:txBody>
+          <a:bodyPr wrap="square">
+            <a:spAutoFit/>
+          </a:bodyPr>
+          <a:lstStyle/>
+          <a:p>
+            <a:r>
+              <a:rPr sz="2800" b="1">
+                <a:solidFill>
+                  <a:srgbClr val="102033"/>
+                </a:solidFill>
+                <a:latin typeface="Microsoft YaHei"/>
+              </a:rPr>
+              <a:t>咨询记录与隐私规则</a:t>
+            </a:r>
+          </a:p>
+          <a:p>
+            <a:pPr>
+              <a:spcBef>
+                <a:spcPts val="1000"/>
+              </a:spcBef>
+            </a:pPr>
+            <a:r>
+              <a:rPr sz="1250">
+                <a:solidFill>
+                  <a:srgbClr val="5A6B7F"/>
+                </a:solidFill>
+                <a:latin typeface="Microsoft YaHei"/>
+              </a:rPr>
+              <a:t>微信是主入口，但真正要沉淀的是结构化摘要，不是聊天原文。</a:t>
+            </a:r>
+          </a:p>
+        </p:txBody>
+      </p:sp>
+      <p:sp>
+        <p:nvSpPr>
+          <p:cNvPr id="6" name="Rounded Rectangle 5"/>
+          <p:cNvSpPr/>
+          <p:nvPr/>
+        </p:nvSpPr>
+        <p:spPr>
+          <a:xfrm>
+            <a:off x="594360" y="1828800"/>
+            <a:ext cx="3703320" cy="2240280"/>
+          </a:xfrm>
+          <a:prstGeom prst="roundRect">
+            <a:avLst/>
+          </a:prstGeom>
+          <a:solidFill>
+            <a:srgbClr val="FFFFFF"/>
+          </a:solidFill>
+          <a:ln>
+            <a:solidFill>
+              <a:srgbClr val="DCE3EB"/>
+            </a:solidFill>
+          </a:ln>
+        </p:spPr>
+        <p:style>
+          <a:lnRef idx="1">
+            <a:schemeClr val="accent1"/>
+          </a:lnRef>
+          <a:fillRef idx="3">
+            <a:schemeClr val="accent1"/>
+          </a:fillRef>
+          <a:effectRef idx="2">
+            <a:schemeClr val="accent1"/>
+          </a:effectRef>
+          <a:fontRef idx="minor">
+            <a:schemeClr val="lt1"/>
+          </a:fontRef>
+        </p:style>
+        <p:txBody>
+          <a:bodyPr rtlCol="0" anchor="ctr"/>
+          <a:lstStyle/>
+          <a:p>
+            <a:pPr algn="ctr"/>
+          </a:p>
+        </p:txBody>
+      </p:sp>
+      <p:sp>
+        <p:nvSpPr>
+          <p:cNvPr id="7" name="Rectangle 6"/>
+          <p:cNvSpPr/>
+          <p:nvPr/>
+        </p:nvSpPr>
+        <p:spPr>
+          <a:xfrm>
+            <a:off x="594360" y="1828800"/>
+            <a:ext cx="109728" cy="2240280"/>
+          </a:xfrm>
+          <a:prstGeom prst="rect">
+            <a:avLst/>
+          </a:prstGeom>
+          <a:solidFill>
+            <a:srgbClr val="22A35C"/>
+          </a:solidFill>
+          <a:ln>
+            <a:noFill/>
+          </a:ln>
+        </p:spPr>
+        <p:style>
+          <a:lnRef idx="1">
+            <a:schemeClr val="accent1"/>
+          </a:lnRef>
+          <a:fillRef idx="3">
+            <a:schemeClr val="accent1"/>
+          </a:fillRef>
+          <a:effectRef idx="2">
+            <a:schemeClr val="accent1"/>
+          </a:effectRef>
+          <a:fontRef idx="minor">
+            <a:schemeClr val="lt1"/>
+          </a:fontRef>
+        </p:style>
+        <p:txBody>
+          <a:bodyPr rtlCol="0" anchor="ctr"/>
+          <a:lstStyle/>
+          <a:p>
+            <a:pPr algn="ctr"/>
+          </a:p>
+        </p:txBody>
+      </p:sp>
+      <p:sp>
+        <p:nvSpPr>
+          <p:cNvPr id="8" name="TextBox 7"/>
+          <p:cNvSpPr txBox="1"/>
+          <p:nvPr/>
+        </p:nvSpPr>
+        <p:spPr>
+          <a:xfrm>
+            <a:off x="822960" y="1993392"/>
+            <a:ext cx="3337560" cy="1965960"/>
+          </a:xfrm>
+          <a:prstGeom prst="rect">
+            <a:avLst/>
+          </a:prstGeom>
+          <a:noFill/>
+        </p:spPr>
+        <p:txBody>
+          <a:bodyPr wrap="square">
+            <a:spAutoFit/>
+          </a:bodyPr>
+          <a:lstStyle/>
+          <a:p>
+            <a:pPr>
+              <a:spcAft>
+                <a:spcPts val="400"/>
+              </a:spcAft>
+            </a:pPr>
+            <a:r>
+              <a:rPr sz="1500" b="1">
+                <a:solidFill>
+                  <a:srgbClr val="102033"/>
+                </a:solidFill>
+                <a:latin typeface="Microsoft YaHei"/>
+              </a:rPr>
+              <a:t>咨询记录字段</a:t>
+            </a:r>
+          </a:p>
+          <a:p>
+            <a:pPr>
+              <a:spcBef>
+                <a:spcPts val="400"/>
+              </a:spcBef>
+            </a:pPr>
+            <a:r>
+              <a:rPr sz="1100">
+                <a:solidFill>
+                  <a:srgbClr val="5A6B7F"/>
+                </a:solidFill>
+                <a:latin typeface="Microsoft YaHei"/>
+              </a:rPr>
+              <a:t/>
+            </a:r>
+          </a:p>
+        </p:txBody>
+      </p:sp>
+      <p:sp>
+        <p:nvSpPr>
+          <p:cNvPr id="9" name="TextBox 8"/>
+          <p:cNvSpPr txBox="1"/>
+          <p:nvPr/>
+        </p:nvSpPr>
+        <p:spPr>
+          <a:xfrm>
+            <a:off x="822960" y="2395728"/>
+            <a:ext cx="3291839" cy="1554480"/>
+          </a:xfrm>
+          <a:prstGeom prst="rect">
+            <a:avLst/>
+          </a:prstGeom>
+          <a:noFill/>
+        </p:spPr>
+        <p:txBody>
+          <a:bodyPr wrap="square">
+            <a:normAutofit/>
+          </a:bodyPr>
+          <a:lstStyle/>
+          <a:p>
+            <a:pPr>
+              <a:spcAft>
+                <a:spcPts val="700"/>
+              </a:spcAft>
+            </a:pPr>
+            <a:r>
+              <a:rPr sz="1200">
+                <a:solidFill>
+                  <a:srgbClr val="102033"/>
+                </a:solidFill>
+                <a:latin typeface="Microsoft YaHei"/>
+              </a:rPr>
+              <a:t>时间</a:t>
+            </a:r>
+          </a:p>
+          <a:p>
+            <a:pPr>
+              <a:spcAft>
+                <a:spcPts val="700"/>
+              </a:spcAft>
+            </a:pPr>
+            <a:r>
+              <a:rPr sz="1200">
+                <a:solidFill>
+                  <a:srgbClr val="102033"/>
+                </a:solidFill>
+                <a:latin typeface="Microsoft YaHei"/>
+              </a:rPr>
+              <a:t>微信昵称 / 微信号</a:t>
+            </a:r>
+          </a:p>
+          <a:p>
+            <a:pPr>
+              <a:spcAft>
+                <a:spcPts val="700"/>
+              </a:spcAft>
+            </a:pPr>
+            <a:r>
+              <a:rPr sz="1200">
+                <a:solidFill>
+                  <a:srgbClr val="102033"/>
+                </a:solidFill>
+                <a:latin typeface="Microsoft YaHei"/>
+              </a:rPr>
+              <a:t>来源页面</a:t>
+            </a:r>
+          </a:p>
+          <a:p>
+            <a:pPr>
+              <a:spcAft>
+                <a:spcPts val="700"/>
+              </a:spcAft>
+            </a:pPr>
+            <a:r>
+              <a:rPr sz="1200">
+                <a:solidFill>
+                  <a:srgbClr val="102033"/>
+                </a:solidFill>
+                <a:latin typeface="Microsoft YaHei"/>
+              </a:rPr>
+              <a:t>课程方向、年级、需求摘要</a:t>
+            </a:r>
+          </a:p>
+        </p:txBody>
+      </p:sp>
+      <p:sp>
+        <p:nvSpPr>
+          <p:cNvPr id="10" name="Rounded Rectangle 9"/>
+          <p:cNvSpPr/>
+          <p:nvPr/>
+        </p:nvSpPr>
+        <p:spPr>
+          <a:xfrm>
+            <a:off x="4434840" y="1828800"/>
+            <a:ext cx="3703320" cy="2240280"/>
+          </a:xfrm>
+          <a:prstGeom prst="roundRect">
+            <a:avLst/>
+          </a:prstGeom>
+          <a:solidFill>
+            <a:srgbClr val="FFFFFF"/>
+          </a:solidFill>
+          <a:ln>
+            <a:solidFill>
+              <a:srgbClr val="DCE3EB"/>
+            </a:solidFill>
+          </a:ln>
+        </p:spPr>
+        <p:style>
+          <a:lnRef idx="1">
+            <a:schemeClr val="accent1"/>
+          </a:lnRef>
+          <a:fillRef idx="3">
+            <a:schemeClr val="accent1"/>
+          </a:fillRef>
+          <a:effectRef idx="2">
+            <a:schemeClr val="accent1"/>
+          </a:effectRef>
+          <a:fontRef idx="minor">
+            <a:schemeClr val="lt1"/>
+          </a:fontRef>
+        </p:style>
+        <p:txBody>
+          <a:bodyPr rtlCol="0" anchor="ctr"/>
+          <a:lstStyle/>
+          <a:p>
+            <a:pPr algn="ctr"/>
+          </a:p>
+        </p:txBody>
+      </p:sp>
+      <p:sp>
+        <p:nvSpPr>
+          <p:cNvPr id="11" name="Rectangle 10"/>
+          <p:cNvSpPr/>
+          <p:nvPr/>
+        </p:nvSpPr>
+        <p:spPr>
+          <a:xfrm>
+            <a:off x="4434840" y="1828800"/>
+            <a:ext cx="109728" cy="2240280"/>
+          </a:xfrm>
+          <a:prstGeom prst="rect">
+            <a:avLst/>
+          </a:prstGeom>
+          <a:solidFill>
+            <a:srgbClr val="EF4444"/>
+          </a:solidFill>
+          <a:ln>
+            <a:noFill/>
+          </a:ln>
+        </p:spPr>
+        <p:style>
+          <a:lnRef idx="1">
+            <a:schemeClr val="accent1"/>
+          </a:lnRef>
+          <a:fillRef idx="3">
+            <a:schemeClr val="accent1"/>
+          </a:fillRef>
+          <a:effectRef idx="2">
+            <a:schemeClr val="accent1"/>
+          </a:effectRef>
+          <a:fontRef idx="minor">
+            <a:schemeClr val="lt1"/>
+          </a:fontRef>
+        </p:style>
+        <p:txBody>
+          <a:bodyPr rtlCol="0" anchor="ctr"/>
+          <a:lstStyle/>
+          <a:p>
+            <a:pPr algn="ctr"/>
+          </a:p>
+        </p:txBody>
+      </p:sp>
+      <p:sp>
+        <p:nvSpPr>
+          <p:cNvPr id="12" name="TextBox 11"/>
+          <p:cNvSpPr txBox="1"/>
+          <p:nvPr/>
+        </p:nvSpPr>
+        <p:spPr>
+          <a:xfrm>
+            <a:off x="4663440" y="1993392"/>
+            <a:ext cx="3337560" cy="1965960"/>
+          </a:xfrm>
+          <a:prstGeom prst="rect">
+            <a:avLst/>
+          </a:prstGeom>
+          <a:noFill/>
+        </p:spPr>
+        <p:txBody>
+          <a:bodyPr wrap="square">
+            <a:spAutoFit/>
+          </a:bodyPr>
+          <a:lstStyle/>
+          <a:p>
+            <a:pPr>
+              <a:spcAft>
+                <a:spcPts val="400"/>
+              </a:spcAft>
+            </a:pPr>
+            <a:r>
+              <a:rPr sz="1500" b="1">
+                <a:solidFill>
+                  <a:srgbClr val="102033"/>
+                </a:solidFill>
+                <a:latin typeface="Microsoft YaHei"/>
+              </a:rPr>
+              <a:t>隐私规则</a:t>
+            </a:r>
+          </a:p>
+          <a:p>
+            <a:pPr>
+              <a:spcBef>
+                <a:spcPts val="400"/>
+              </a:spcBef>
+            </a:pPr>
+            <a:r>
+              <a:rPr sz="1100">
+                <a:solidFill>
+                  <a:srgbClr val="5A6B7F"/>
+                </a:solidFill>
+                <a:latin typeface="Microsoft YaHei"/>
+              </a:rPr>
+              <a:t/>
+            </a:r>
+          </a:p>
+        </p:txBody>
+      </p:sp>
+      <p:sp>
+        <p:nvSpPr>
+          <p:cNvPr id="13" name="TextBox 12"/>
+          <p:cNvSpPr txBox="1"/>
+          <p:nvPr/>
+        </p:nvSpPr>
+        <p:spPr>
+          <a:xfrm>
+            <a:off x="4663440" y="2395728"/>
+            <a:ext cx="3291839" cy="1554480"/>
+          </a:xfrm>
+          <a:prstGeom prst="rect">
+            <a:avLst/>
+          </a:prstGeom>
+          <a:noFill/>
+        </p:spPr>
+        <p:txBody>
+          <a:bodyPr wrap="square">
+            <a:normAutofit/>
+          </a:bodyPr>
+          <a:lstStyle/>
+          <a:p>
+            <a:pPr>
+              <a:spcAft>
+                <a:spcPts val="700"/>
+              </a:spcAft>
+            </a:pPr>
+            <a:r>
+              <a:rPr sz="1200">
+                <a:solidFill>
+                  <a:srgbClr val="102033"/>
+                </a:solidFill>
+                <a:latin typeface="Microsoft YaHei"/>
+              </a:rPr>
+              <a:t>不存完整聊天原文</a:t>
+            </a:r>
+          </a:p>
+          <a:p>
+            <a:pPr>
+              <a:spcAft>
+                <a:spcPts val="700"/>
+              </a:spcAft>
+            </a:pPr>
+            <a:r>
+              <a:rPr sz="1200">
+                <a:solidFill>
+                  <a:srgbClr val="102033"/>
+                </a:solidFill>
+                <a:latin typeface="Microsoft YaHei"/>
+              </a:rPr>
+              <a:t>不长期保留截图和语音</a:t>
+            </a:r>
+          </a:p>
+          <a:p>
+            <a:pPr>
+              <a:spcAft>
+                <a:spcPts val="700"/>
+              </a:spcAft>
+            </a:pPr>
+            <a:r>
+              <a:rPr sz="1200">
+                <a:solidFill>
+                  <a:srgbClr val="102033"/>
+                </a:solidFill>
+                <a:latin typeface="Microsoft YaHei"/>
+              </a:rPr>
+              <a:t>孩子学校、班级等敏感信息少存或匿名化</a:t>
+            </a:r>
+          </a:p>
+        </p:txBody>
+      </p:sp>
+      <p:sp>
+        <p:nvSpPr>
+          <p:cNvPr id="14" name="Rounded Rectangle 13"/>
+          <p:cNvSpPr/>
+          <p:nvPr/>
+        </p:nvSpPr>
+        <p:spPr>
+          <a:xfrm>
+            <a:off x="8275320" y="1828800"/>
+            <a:ext cx="3246120" cy="2240280"/>
+          </a:xfrm>
+          <a:prstGeom prst="roundRect">
+            <a:avLst/>
+          </a:prstGeom>
+          <a:solidFill>
+            <a:srgbClr val="FFFFFF"/>
+          </a:solidFill>
+          <a:ln>
+            <a:solidFill>
+              <a:srgbClr val="DCE3EB"/>
+            </a:solidFill>
+          </a:ln>
+        </p:spPr>
+        <p:style>
+          <a:lnRef idx="1">
+            <a:schemeClr val="accent1"/>
+          </a:lnRef>
+          <a:fillRef idx="3">
+            <a:schemeClr val="accent1"/>
+          </a:fillRef>
+          <a:effectRef idx="2">
+            <a:schemeClr val="accent1"/>
+          </a:effectRef>
+          <a:fontRef idx="minor">
+            <a:schemeClr val="lt1"/>
+          </a:fontRef>
+        </p:style>
+        <p:txBody>
+          <a:bodyPr rtlCol="0" anchor="ctr"/>
+          <a:lstStyle/>
+          <a:p>
+            <a:pPr algn="ctr"/>
+          </a:p>
+        </p:txBody>
+      </p:sp>
+      <p:sp>
+        <p:nvSpPr>
+          <p:cNvPr id="15" name="Rectangle 14"/>
+          <p:cNvSpPr/>
+          <p:nvPr/>
+        </p:nvSpPr>
+        <p:spPr>
+          <a:xfrm>
+            <a:off x="8275320" y="1828800"/>
+            <a:ext cx="109728" cy="2240280"/>
+          </a:xfrm>
+          <a:prstGeom prst="rect">
+            <a:avLst/>
+          </a:prstGeom>
+          <a:solidFill>
+            <a:srgbClr val="1B6DFF"/>
+          </a:solidFill>
+          <a:ln>
+            <a:noFill/>
+          </a:ln>
+        </p:spPr>
+        <p:style>
+          <a:lnRef idx="1">
+            <a:schemeClr val="accent1"/>
+          </a:lnRef>
+          <a:fillRef idx="3">
+            <a:schemeClr val="accent1"/>
+          </a:fillRef>
+          <a:effectRef idx="2">
+            <a:schemeClr val="accent1"/>
+          </a:effectRef>
+          <a:fontRef idx="minor">
+            <a:schemeClr val="lt1"/>
+          </a:fontRef>
+        </p:style>
+        <p:txBody>
+          <a:bodyPr rtlCol="0" anchor="ctr"/>
+          <a:lstStyle/>
+          <a:p>
+            <a:pPr algn="ctr"/>
+          </a:p>
+        </p:txBody>
+      </p:sp>
+      <p:sp>
+        <p:nvSpPr>
+          <p:cNvPr id="16" name="TextBox 15"/>
+          <p:cNvSpPr txBox="1"/>
+          <p:nvPr/>
+        </p:nvSpPr>
+        <p:spPr>
+          <a:xfrm>
+            <a:off x="8503920" y="1993392"/>
+            <a:ext cx="2880360" cy="1965960"/>
+          </a:xfrm>
+          <a:prstGeom prst="rect">
+            <a:avLst/>
+          </a:prstGeom>
+          <a:noFill/>
+        </p:spPr>
+        <p:txBody>
+          <a:bodyPr wrap="square">
+            <a:spAutoFit/>
+          </a:bodyPr>
+          <a:lstStyle/>
+          <a:p>
+            <a:pPr>
+              <a:spcAft>
+                <a:spcPts val="400"/>
+              </a:spcAft>
+            </a:pPr>
+            <a:r>
+              <a:rPr sz="1500" b="1">
+                <a:solidFill>
+                  <a:srgbClr val="102033"/>
+                </a:solidFill>
+                <a:latin typeface="Microsoft YaHei"/>
+              </a:rPr>
+              <a:t>每周复盘</a:t>
+            </a:r>
+          </a:p>
+          <a:p>
+            <a:pPr>
+              <a:spcBef>
+                <a:spcPts val="400"/>
+              </a:spcBef>
+            </a:pPr>
+            <a:r>
+              <a:rPr sz="1100">
+                <a:solidFill>
+                  <a:srgbClr val="5A6B7F"/>
+                </a:solidFill>
+                <a:latin typeface="Microsoft YaHei"/>
+              </a:rPr>
+              <a:t/>
+            </a:r>
+          </a:p>
+        </p:txBody>
+      </p:sp>
+      <p:sp>
+        <p:nvSpPr>
+          <p:cNvPr id="17" name="TextBox 16"/>
+          <p:cNvSpPr txBox="1"/>
+          <p:nvPr/>
+        </p:nvSpPr>
+        <p:spPr>
+          <a:xfrm>
+            <a:off x="8503920" y="2395728"/>
+            <a:ext cx="2834639" cy="1554480"/>
+          </a:xfrm>
+          <a:prstGeom prst="rect">
+            <a:avLst/>
+          </a:prstGeom>
+          <a:noFill/>
+        </p:spPr>
+        <p:txBody>
+          <a:bodyPr wrap="square">
+            <a:normAutofit/>
+          </a:bodyPr>
+          <a:lstStyle/>
+          <a:p>
+            <a:pPr>
+              <a:spcAft>
+                <a:spcPts val="700"/>
+              </a:spcAft>
+            </a:pPr>
+            <a:r>
+              <a:rPr sz="1200">
+                <a:solidFill>
+                  <a:srgbClr val="102033"/>
+                </a:solidFill>
+                <a:latin typeface="Microsoft YaHei"/>
+              </a:rPr>
+              <a:t>哪个课程最多</a:t>
+            </a:r>
+          </a:p>
+          <a:p>
+            <a:pPr>
+              <a:spcAft>
+                <a:spcPts val="700"/>
+              </a:spcAft>
+            </a:pPr>
+            <a:r>
+              <a:rPr sz="1200">
+                <a:solidFill>
+                  <a:srgbClr val="102033"/>
+                </a:solidFill>
+                <a:latin typeface="Microsoft YaHei"/>
+              </a:rPr>
+              <a:t>哪个入口最有效</a:t>
+            </a:r>
+          </a:p>
+          <a:p>
+            <a:pPr>
+              <a:spcAft>
+                <a:spcPts val="700"/>
+              </a:spcAft>
+            </a:pPr>
+            <a:r>
+              <a:rPr sz="1200">
+                <a:solidFill>
+                  <a:srgbClr val="102033"/>
+                </a:solidFill>
+                <a:latin typeface="Microsoft YaHei"/>
+              </a:rPr>
+              <a:t>微信 / WhatsApp 谁转化更高</a:t>
+            </a:r>
+          </a:p>
+        </p:txBody>
+      </p:sp>
+      <p:sp>
+        <p:nvSpPr>
+          <p:cNvPr id="18" name="Rounded Rectangle 17"/>
+          <p:cNvSpPr/>
+          <p:nvPr/>
+        </p:nvSpPr>
+        <p:spPr>
+          <a:xfrm>
+            <a:off x="594360" y="4389120"/>
+            <a:ext cx="10972800" cy="1051560"/>
+          </a:xfrm>
+          <a:prstGeom prst="roundRect">
+            <a:avLst/>
+          </a:prstGeom>
+          <a:solidFill>
+            <a:srgbClr val="F4F7FB"/>
+          </a:solidFill>
+          <a:ln>
+            <a:solidFill>
+              <a:srgbClr val="DCE3EB"/>
+            </a:solidFill>
+          </a:ln>
+        </p:spPr>
+        <p:style>
+          <a:lnRef idx="1">
+            <a:schemeClr val="accent1"/>
+          </a:lnRef>
+          <a:fillRef idx="3">
+            <a:schemeClr val="accent1"/>
+          </a:fillRef>
+          <a:effectRef idx="2">
+            <a:schemeClr val="accent1"/>
+          </a:effectRef>
+          <a:fontRef idx="minor">
+            <a:schemeClr val="lt1"/>
+          </a:fontRef>
+        </p:style>
+        <p:txBody>
+          <a:bodyPr rtlCol="0" anchor="ctr"/>
+          <a:lstStyle/>
+          <a:p>
+            <a:pPr algn="ctr"/>
+          </a:p>
+        </p:txBody>
+      </p:sp>
+      <p:sp>
+        <p:nvSpPr>
+          <p:cNvPr id="19" name="Rectangle 18"/>
+          <p:cNvSpPr/>
+          <p:nvPr/>
+        </p:nvSpPr>
+        <p:spPr>
+          <a:xfrm>
+            <a:off x="594360" y="4389120"/>
+            <a:ext cx="109728" cy="1051560"/>
+          </a:xfrm>
+          <a:prstGeom prst="rect">
+            <a:avLst/>
+          </a:prstGeom>
+          <a:solidFill>
+            <a:srgbClr val="19C4B0"/>
+          </a:solidFill>
+          <a:ln>
+            <a:noFill/>
+          </a:ln>
+        </p:spPr>
+        <p:style>
+          <a:lnRef idx="1">
+            <a:schemeClr val="accent1"/>
+          </a:lnRef>
+          <a:fillRef idx="3">
+            <a:schemeClr val="accent1"/>
+          </a:fillRef>
+          <a:effectRef idx="2">
+            <a:schemeClr val="accent1"/>
+          </a:effectRef>
+          <a:fontRef idx="minor">
+            <a:schemeClr val="lt1"/>
+          </a:fontRef>
+        </p:style>
+        <p:txBody>
+          <a:bodyPr rtlCol="0" anchor="ctr"/>
+          <a:lstStyle/>
+          <a:p>
+            <a:pPr algn="ctr"/>
+          </a:p>
+        </p:txBody>
+      </p:sp>
+      <p:sp>
+        <p:nvSpPr>
+          <p:cNvPr id="20" name="TextBox 19"/>
+          <p:cNvSpPr txBox="1"/>
+          <p:nvPr/>
+        </p:nvSpPr>
+        <p:spPr>
+          <a:xfrm>
+            <a:off x="822960" y="4553712"/>
+            <a:ext cx="10607040" cy="777239"/>
+          </a:xfrm>
+          <a:prstGeom prst="rect">
+            <a:avLst/>
+          </a:prstGeom>
+          <a:noFill/>
+        </p:spPr>
+        <p:txBody>
+          <a:bodyPr wrap="square">
+            <a:spAutoFit/>
+          </a:bodyPr>
+          <a:lstStyle/>
+          <a:p>
+            <a:pPr>
+              <a:spcAft>
+                <a:spcPts val="400"/>
+              </a:spcAft>
+            </a:pPr>
+            <a:r>
+              <a:rPr sz="1500" b="1">
+                <a:solidFill>
+                  <a:srgbClr val="102033"/>
+                </a:solidFill>
+                <a:latin typeface="Microsoft YaHei"/>
+              </a:rPr>
+              <a:t>最实用的原则</a:t>
+            </a:r>
+          </a:p>
+          <a:p>
+            <a:pPr>
+              <a:spcBef>
+                <a:spcPts val="400"/>
+              </a:spcBef>
+            </a:pPr>
+            <a:r>
+              <a:rPr sz="1200">
+                <a:solidFill>
+                  <a:srgbClr val="5A6B7F"/>
+                </a:solidFill>
+                <a:latin typeface="Microsoft YaHei"/>
+              </a:rPr>
+              <a:t>记录结果，不记录过程；保留摘要，不保留全文；看汇总，不看隐私原文。</a:t>
+            </a:r>
+          </a:p>
+        </p:txBody>
+      </p:sp>
+      <p:sp>
+        <p:nvSpPr>
+          <p:cNvPr id="21" name="TextBox 20"/>
+          <p:cNvSpPr txBox="1"/>
+          <p:nvPr/>
+        </p:nvSpPr>
+        <p:spPr>
+          <a:xfrm>
+            <a:off x="594360" y="5623560"/>
+            <a:ext cx="10972800" cy="365760"/>
+          </a:xfrm>
+          <a:prstGeom prst="rect">
+            <a:avLst/>
+          </a:prstGeom>
+          <a:noFill/>
+        </p:spPr>
+        <p:txBody>
+          <a:bodyPr wrap="none">
+            <a:spAutoFit/>
+          </a:bodyPr>
+          <a:lstStyle/>
+          <a:p>
+            <a:pPr algn="r"/>
+            <a:r>
+              <a:rPr sz="1150">
+                <a:solidFill>
+                  <a:srgbClr val="5A6B7F"/>
+                </a:solidFill>
+                <a:latin typeface="Microsoft YaHei"/>
+              </a:rPr>
+              <a:t>建议形式：Excel / Google Sheet / 企业微信后续接入。</a:t>
+            </a:r>
+          </a:p>
+        </p:txBody>
+      </p:sp>
+    </p:spTree>
+  </p:cSld>
+  <p:clrMapOvr>
+    <a:masterClrMapping/>
+  </p:clrMapOvr>
+</p:sld>
+</file>
+
+<file path=ppt/slides/slide9.xml><?xml version="1.0" encoding="utf-8"?>
 <p:sld xmlns:a="http://schemas.openxmlformats.org/drawingml/2006/main" xmlns:p="http://schemas.openxmlformats.org/presentationml/2006/main" xmlns:r="http://schemas.openxmlformats.org/officeDocument/2006/relationships">
   <p:cSld>
     <p:bg>

</xml_diff>

<commit_message>
Add WeChat record template slide
</commit_message>
<xml_diff>
--- a/IvyEuro_Education_网站改造分析报告.pptx
+++ b/IvyEuro_Education_网站改造分析报告.pptx
@@ -14,6 +14,7 @@
     <p:sldId id="262" r:id="rId13"/>
     <p:sldId id="263" r:id="rId14"/>
     <p:sldId id="264" r:id="rId15"/>
+    <p:sldId id="265" r:id="rId16"/>
   </p:sldIdLst>
   <p:sldSz cx="12191695" cy="6858000" type="screen4x3"/>
   <p:notesSz cx="6858000" cy="9144000"/>
@@ -3527,6 +3528,327 @@
 </p:sld>
 </file>
 
+<file path=ppt/slides/slide10.xml><?xml version="1.0" encoding="utf-8"?>
+<p:sld xmlns:a="http://schemas.openxmlformats.org/drawingml/2006/main" xmlns:p="http://schemas.openxmlformats.org/presentationml/2006/main" xmlns:r="http://schemas.openxmlformats.org/officeDocument/2006/relationships">
+  <p:cSld>
+    <p:bg>
+      <p:bgPr>
+        <a:solidFill>
+          <a:srgbClr val="0B1220"/>
+        </a:solidFill>
+        <a:effectLst/>
+      </p:bgPr>
+    </p:bg>
+    <p:spTree>
+      <p:nvGrpSpPr>
+        <p:cNvPr id="1" name=""/>
+        <p:cNvGrpSpPr/>
+        <p:nvPr/>
+      </p:nvGrpSpPr>
+      <p:grpSpPr/>
+      <p:sp>
+        <p:nvSpPr>
+          <p:cNvPr id="2" name="Rectangle 1"/>
+          <p:cNvSpPr/>
+          <p:nvPr/>
+        </p:nvSpPr>
+        <p:spPr>
+          <a:xfrm>
+            <a:off x="0" y="0"/>
+            <a:ext cx="12191695" cy="841248"/>
+          </a:xfrm>
+          <a:prstGeom prst="rect">
+            <a:avLst/>
+          </a:prstGeom>
+          <a:solidFill>
+            <a:srgbClr val="0B1220"/>
+          </a:solidFill>
+          <a:ln>
+            <a:noFill/>
+          </a:ln>
+        </p:spPr>
+        <p:style>
+          <a:lnRef idx="1">
+            <a:schemeClr val="accent1"/>
+          </a:lnRef>
+          <a:fillRef idx="3">
+            <a:schemeClr val="accent1"/>
+          </a:fillRef>
+          <a:effectRef idx="2">
+            <a:schemeClr val="accent1"/>
+          </a:effectRef>
+          <a:fontRef idx="minor">
+            <a:schemeClr val="lt1"/>
+          </a:fontRef>
+        </p:style>
+        <p:txBody>
+          <a:bodyPr rtlCol="0" anchor="ctr"/>
+          <a:lstStyle/>
+          <a:p>
+            <a:pPr algn="ctr"/>
+          </a:p>
+        </p:txBody>
+      </p:sp>
+      <p:sp>
+        <p:nvSpPr>
+          <p:cNvPr id="3" name="TextBox 2"/>
+          <p:cNvSpPr txBox="1"/>
+          <p:nvPr/>
+        </p:nvSpPr>
+        <p:spPr>
+          <a:xfrm>
+            <a:off x="502920" y="164592"/>
+            <a:ext cx="9692640" cy="384048"/>
+          </a:xfrm>
+          <a:prstGeom prst="rect">
+            <a:avLst/>
+          </a:prstGeom>
+          <a:noFill/>
+        </p:spPr>
+        <p:txBody>
+          <a:bodyPr wrap="none">
+            <a:spAutoFit/>
+          </a:bodyPr>
+          <a:lstStyle/>
+          <a:p>
+            <a:r>
+              <a:rPr sz="2000" b="1">
+                <a:solidFill>
+                  <a:srgbClr val="FFFFFF"/>
+                </a:solidFill>
+                <a:latin typeface="Microsoft YaHei"/>
+              </a:rPr>
+              <a:t>结论与下一步</a:t>
+            </a:r>
+          </a:p>
+        </p:txBody>
+      </p:sp>
+      <p:sp>
+        <p:nvSpPr>
+          <p:cNvPr id="4" name="TextBox 3"/>
+          <p:cNvSpPr txBox="1"/>
+          <p:nvPr/>
+        </p:nvSpPr>
+        <p:spPr>
+          <a:xfrm>
+            <a:off x="8412480" y="182880"/>
+            <a:ext cx="3291840" cy="310896"/>
+          </a:xfrm>
+          <a:prstGeom prst="rect">
+            <a:avLst/>
+          </a:prstGeom>
+          <a:noFill/>
+        </p:spPr>
+        <p:txBody>
+          <a:bodyPr wrap="none">
+            <a:spAutoFit/>
+          </a:bodyPr>
+          <a:lstStyle/>
+          <a:p>
+            <a:pPr algn="r"/>
+            <a:r>
+              <a:rPr sz="1050">
+                <a:solidFill>
+                  <a:srgbClr val="CCD6E0"/>
+                </a:solidFill>
+                <a:latin typeface="Microsoft YaHei"/>
+              </a:rPr>
+              <a:t>交付 / 补强 / 上线</a:t>
+            </a:r>
+          </a:p>
+        </p:txBody>
+      </p:sp>
+      <p:sp>
+        <p:nvSpPr>
+          <p:cNvPr id="5" name="Rounded Rectangle 4"/>
+          <p:cNvSpPr/>
+          <p:nvPr/>
+        </p:nvSpPr>
+        <p:spPr>
+          <a:xfrm>
+            <a:off x="685800" y="1097280"/>
+            <a:ext cx="10789920" cy="4937760"/>
+          </a:xfrm>
+          <a:prstGeom prst="roundRect">
+            <a:avLst/>
+          </a:prstGeom>
+          <a:solidFill>
+            <a:srgbClr val="111B2C"/>
+          </a:solidFill>
+          <a:ln>
+            <a:solidFill>
+              <a:srgbClr val="303E54"/>
+            </a:solidFill>
+          </a:ln>
+        </p:spPr>
+        <p:style>
+          <a:lnRef idx="1">
+            <a:schemeClr val="accent1"/>
+          </a:lnRef>
+          <a:fillRef idx="3">
+            <a:schemeClr val="accent1"/>
+          </a:fillRef>
+          <a:effectRef idx="2">
+            <a:schemeClr val="accent1"/>
+          </a:effectRef>
+          <a:fontRef idx="minor">
+            <a:schemeClr val="lt1"/>
+          </a:fontRef>
+        </p:style>
+        <p:txBody>
+          <a:bodyPr rtlCol="0" anchor="ctr"/>
+          <a:lstStyle/>
+          <a:p>
+            <a:pPr algn="ctr"/>
+          </a:p>
+        </p:txBody>
+      </p:sp>
+      <p:sp>
+        <p:nvSpPr>
+          <p:cNvPr id="6" name="TextBox 5"/>
+          <p:cNvSpPr txBox="1"/>
+          <p:nvPr/>
+        </p:nvSpPr>
+        <p:spPr>
+          <a:xfrm>
+            <a:off x="1005840" y="1463040"/>
+            <a:ext cx="9875520" cy="4206240"/>
+          </a:xfrm>
+          <a:prstGeom prst="rect">
+            <a:avLst/>
+          </a:prstGeom>
+          <a:noFill/>
+        </p:spPr>
+        <p:txBody>
+          <a:bodyPr wrap="square">
+            <a:spAutoFit/>
+          </a:bodyPr>
+          <a:lstStyle/>
+          <a:p>
+            <a:pPr>
+              <a:spcAft>
+                <a:spcPts val="1400"/>
+              </a:spcAft>
+            </a:pPr>
+            <a:r>
+              <a:rPr sz="1700" b="1">
+                <a:solidFill>
+                  <a:srgbClr val="FFFFFF"/>
+                </a:solidFill>
+                <a:latin typeface="Microsoft YaHei"/>
+              </a:rPr>
+              <a:t>1. 当前网站已完成结构重建，核心业务内容已迁移。</a:t>
+            </a:r>
+          </a:p>
+          <a:p>
+            <a:pPr>
+              <a:spcAft>
+                <a:spcPts val="1400"/>
+              </a:spcAft>
+            </a:pPr>
+            <a:r>
+              <a:rPr sz="1500" b="0">
+                <a:solidFill>
+                  <a:srgbClr val="FFFFFF"/>
+                </a:solidFill>
+                <a:latin typeface="Microsoft YaHei"/>
+              </a:rPr>
+              <a:t>2. 暑期课程已改为季节性公告，避免长期占用首页。</a:t>
+            </a:r>
+          </a:p>
+          <a:p>
+            <a:pPr>
+              <a:spcAft>
+                <a:spcPts val="1400"/>
+              </a:spcAft>
+            </a:pPr>
+            <a:r>
+              <a:rPr sz="1500" b="0">
+                <a:solidFill>
+                  <a:srgbClr val="FFFFFF"/>
+                </a:solidFill>
+                <a:latin typeface="Microsoft YaHei"/>
+              </a:rPr>
+              <a:t>3. 微信、WhatsApp、二维码、电话、表单都已经统一。</a:t>
+            </a:r>
+          </a:p>
+          <a:p>
+            <a:pPr>
+              <a:spcAft>
+                <a:spcPts val="1400"/>
+              </a:spcAft>
+            </a:pPr>
+            <a:r>
+              <a:rPr sz="1500" b="0">
+                <a:solidFill>
+                  <a:srgbClr val="FFFFFF"/>
+                </a:solidFill>
+                <a:latin typeface="Microsoft YaHei"/>
+              </a:rPr>
+              <a:t>4. 后续最重要的是补老师真实资料、家长真实评价和真实新闻。</a:t>
+            </a:r>
+          </a:p>
+          <a:p>
+            <a:pPr>
+              <a:spcAft>
+                <a:spcPts val="1400"/>
+              </a:spcAft>
+            </a:pPr>
+            <a:r>
+              <a:rPr sz="1500" b="0">
+                <a:solidFill>
+                  <a:srgbClr val="FFFFFF"/>
+                </a:solidFill>
+                <a:latin typeface="Microsoft YaHei"/>
+              </a:rPr>
+              <a:t>5. 完成后即可进入最终上线前检查与部署。</a:t>
+            </a:r>
+          </a:p>
+        </p:txBody>
+      </p:sp>
+      <p:sp>
+        <p:nvSpPr>
+          <p:cNvPr id="7" name="TextBox 6"/>
+          <p:cNvSpPr txBox="1"/>
+          <p:nvPr/>
+        </p:nvSpPr>
+        <p:spPr>
+          <a:xfrm>
+            <a:off x="822960" y="6126480"/>
+            <a:ext cx="10515600" cy="365760"/>
+          </a:xfrm>
+          <a:prstGeom prst="rect">
+            <a:avLst/>
+          </a:prstGeom>
+          <a:noFill/>
+        </p:spPr>
+        <p:txBody>
+          <a:bodyPr wrap="none">
+            <a:spAutoFit/>
+          </a:bodyPr>
+          <a:lstStyle/>
+          <a:p>
+            <a:pPr algn="r"/>
+            <a:r>
+              <a:rPr sz="1100">
+                <a:solidFill>
+                  <a:srgbClr val="CDD6E0"/>
+                </a:solidFill>
+                <a:latin typeface="Microsoft YaHei"/>
+              </a:rPr>
+              <a:t>IvyEuro Education · 网站改造分析报告</a:t>
+            </a:r>
+          </a:p>
+        </p:txBody>
+      </p:sp>
+    </p:spTree>
+  </p:cSld>
+  <p:clrMapOvr>
+    <a:masterClrMapping/>
+  </p:clrMapOvr>
+</p:sld>
+</file>
+
 <file path=ppt/slides/slide2.xml><?xml version="1.0" encoding="utf-8"?>
 <p:sld xmlns:a="http://schemas.openxmlformats.org/drawingml/2006/main" xmlns:p="http://schemas.openxmlformats.org/presentationml/2006/main" xmlns:r="http://schemas.openxmlformats.org/officeDocument/2006/relationships">
   <p:cSld>
@@ -10265,7 +10587,7 @@
     <p:bg>
       <p:bgPr>
         <a:solidFill>
-          <a:srgbClr val="0B1220"/>
+          <a:srgbClr val="FFFFFF"/>
         </a:solidFill>
         <a:effectLst/>
       </p:bgPr>
@@ -10349,7 +10671,7 @@
                 </a:solidFill>
                 <a:latin typeface="Microsoft YaHei"/>
               </a:rPr>
-              <a:t>结论与下一步</a:t>
+              <a:t>微信记录模板</a:t>
             </a:r>
           </a:p>
         </p:txBody>
@@ -10384,31 +10706,81 @@
                 </a:solidFill>
                 <a:latin typeface="Microsoft YaHei"/>
               </a:rPr>
-              <a:t>交付 / 补强 / 上线</a:t>
-            </a:r>
-          </a:p>
-        </p:txBody>
-      </p:sp>
-      <p:sp>
-        <p:nvSpPr>
-          <p:cNvPr id="5" name="Rounded Rectangle 4"/>
+              <a:t>可直接复制使用</a:t>
+            </a:r>
+          </a:p>
+        </p:txBody>
+      </p:sp>
+      <p:sp>
+        <p:nvSpPr>
+          <p:cNvPr id="5" name="TextBox 4"/>
+          <p:cNvSpPr txBox="1"/>
+          <p:nvPr/>
+        </p:nvSpPr>
+        <p:spPr>
+          <a:xfrm>
+            <a:off x="594360" y="1051560"/>
+            <a:ext cx="10789920" cy="1280160"/>
+          </a:xfrm>
+          <a:prstGeom prst="rect">
+            <a:avLst/>
+          </a:prstGeom>
+          <a:noFill/>
+        </p:spPr>
+        <p:txBody>
+          <a:bodyPr wrap="square">
+            <a:spAutoFit/>
+          </a:bodyPr>
+          <a:lstStyle/>
+          <a:p>
+            <a:r>
+              <a:rPr sz="2800" b="1">
+                <a:solidFill>
+                  <a:srgbClr val="102033"/>
+                </a:solidFill>
+                <a:latin typeface="Microsoft YaHei"/>
+              </a:rPr>
+              <a:t>咨询记录与示例</a:t>
+            </a:r>
+          </a:p>
+          <a:p>
+            <a:pPr>
+              <a:spcBef>
+                <a:spcPts val="1000"/>
+              </a:spcBef>
+            </a:pPr>
+            <a:r>
+              <a:rPr sz="1250">
+                <a:solidFill>
+                  <a:srgbClr val="5A6B7F"/>
+                </a:solidFill>
+                <a:latin typeface="Microsoft YaHei"/>
+              </a:rPr>
+              <a:t>把咨询记录统一成结构化字段，方便后续统计和复盘。</a:t>
+            </a:r>
+          </a:p>
+        </p:txBody>
+      </p:sp>
+      <p:sp>
+        <p:nvSpPr>
+          <p:cNvPr id="6" name="Rounded Rectangle 5"/>
           <p:cNvSpPr/>
           <p:nvPr/>
         </p:nvSpPr>
         <p:spPr>
           <a:xfrm>
-            <a:off x="685800" y="1097280"/>
-            <a:ext cx="10789920" cy="4937760"/>
+            <a:off x="594360" y="1828800"/>
+            <a:ext cx="3749039" cy="2331720"/>
           </a:xfrm>
           <a:prstGeom prst="roundRect">
             <a:avLst/>
           </a:prstGeom>
           <a:solidFill>
-            <a:srgbClr val="111B2C"/>
+            <a:srgbClr val="FFFFFF"/>
           </a:solidFill>
           <a:ln>
             <a:solidFill>
-              <a:srgbClr val="303E54"/>
+              <a:srgbClr val="DCE3EB"/>
             </a:solidFill>
           </a:ln>
         </p:spPr>
@@ -10436,14 +10808,57 @@
       </p:sp>
       <p:sp>
         <p:nvSpPr>
-          <p:cNvPr id="6" name="TextBox 5"/>
+          <p:cNvPr id="7" name="Rectangle 6"/>
+          <p:cNvSpPr/>
+          <p:nvPr/>
+        </p:nvSpPr>
+        <p:spPr>
+          <a:xfrm>
+            <a:off x="594360" y="1828800"/>
+            <a:ext cx="109728" cy="2331720"/>
+          </a:xfrm>
+          <a:prstGeom prst="rect">
+            <a:avLst/>
+          </a:prstGeom>
+          <a:solidFill>
+            <a:srgbClr val="1B6DFF"/>
+          </a:solidFill>
+          <a:ln>
+            <a:noFill/>
+          </a:ln>
+        </p:spPr>
+        <p:style>
+          <a:lnRef idx="1">
+            <a:schemeClr val="accent1"/>
+          </a:lnRef>
+          <a:fillRef idx="3">
+            <a:schemeClr val="accent1"/>
+          </a:fillRef>
+          <a:effectRef idx="2">
+            <a:schemeClr val="accent1"/>
+          </a:effectRef>
+          <a:fontRef idx="minor">
+            <a:schemeClr val="lt1"/>
+          </a:fontRef>
+        </p:style>
+        <p:txBody>
+          <a:bodyPr rtlCol="0" anchor="ctr"/>
+          <a:lstStyle/>
+          <a:p>
+            <a:pPr algn="ctr"/>
+          </a:p>
+        </p:txBody>
+      </p:sp>
+      <p:sp>
+        <p:nvSpPr>
+          <p:cNvPr id="8" name="TextBox 7"/>
           <p:cNvSpPr txBox="1"/>
           <p:nvPr/>
         </p:nvSpPr>
         <p:spPr>
           <a:xfrm>
-            <a:off x="1005840" y="1463040"/>
-            <a:ext cx="9875520" cy="4206240"/>
+            <a:off x="822960" y="1993392"/>
+            <a:ext cx="3383279" cy="2057400"/>
           </a:xfrm>
           <a:prstGeom prst="rect">
             <a:avLst/>
@@ -10458,95 +10873,359 @@
           <a:p>
             <a:pPr>
               <a:spcAft>
-                <a:spcPts val="1400"/>
+                <a:spcPts val="400"/>
               </a:spcAft>
             </a:pPr>
             <a:r>
-              <a:rPr sz="1700" b="1">
-                <a:solidFill>
-                  <a:srgbClr val="FFFFFF"/>
-                </a:solidFill>
-                <a:latin typeface="Microsoft YaHei"/>
-              </a:rPr>
-              <a:t>1. 当前网站已完成结构重建，核心业务内容已迁移。</a:t>
-            </a:r>
-          </a:p>
+              <a:rPr sz="1500" b="1">
+                <a:solidFill>
+                  <a:srgbClr val="102033"/>
+                </a:solidFill>
+                <a:latin typeface="Microsoft YaHei"/>
+              </a:rPr>
+              <a:t>Excel / Sheet 表头</a:t>
+            </a:r>
+          </a:p>
+          <a:p>
+            <a:pPr>
+              <a:spcBef>
+                <a:spcPts val="400"/>
+              </a:spcBef>
+            </a:pPr>
+            <a:r>
+              <a:rPr sz="1100">
+                <a:solidFill>
+                  <a:srgbClr val="5A6B7F"/>
+                </a:solidFill>
+                <a:latin typeface="Microsoft YaHei"/>
+              </a:rPr>
+              <a:t/>
+            </a:r>
+          </a:p>
+        </p:txBody>
+      </p:sp>
+      <p:sp>
+        <p:nvSpPr>
+          <p:cNvPr id="9" name="TextBox 8"/>
+          <p:cNvSpPr txBox="1"/>
+          <p:nvPr/>
+        </p:nvSpPr>
+        <p:spPr>
+          <a:xfrm>
+            <a:off x="822960" y="2395728"/>
+            <a:ext cx="3337559" cy="1645919"/>
+          </a:xfrm>
+          <a:prstGeom prst="rect">
+            <a:avLst/>
+          </a:prstGeom>
+          <a:noFill/>
+        </p:spPr>
+        <p:txBody>
+          <a:bodyPr wrap="square">
+            <a:normAutofit/>
+          </a:bodyPr>
+          <a:lstStyle/>
           <a:p>
             <a:pPr>
               <a:spcAft>
-                <a:spcPts val="1400"/>
+                <a:spcPts val="700"/>
               </a:spcAft>
             </a:pPr>
             <a:r>
-              <a:rPr sz="1500" b="0">
-                <a:solidFill>
-                  <a:srgbClr val="FFFFFF"/>
-                </a:solidFill>
-                <a:latin typeface="Microsoft YaHei"/>
-              </a:rPr>
-              <a:t>2. 暑期课程已改为季节性公告，避免长期占用首页。</a:t>
+              <a:rPr sz="1200">
+                <a:solidFill>
+                  <a:srgbClr val="102033"/>
+                </a:solidFill>
+                <a:latin typeface="Microsoft YaHei"/>
+              </a:rPr>
+              <a:t>编号、时间、微信昵称、微信号</a:t>
             </a:r>
           </a:p>
           <a:p>
             <a:pPr>
               <a:spcAft>
-                <a:spcPts val="1400"/>
+                <a:spcPts val="700"/>
               </a:spcAft>
             </a:pPr>
             <a:r>
-              <a:rPr sz="1500" b="0">
-                <a:solidFill>
-                  <a:srgbClr val="FFFFFF"/>
-                </a:solidFill>
-                <a:latin typeface="Microsoft YaHei"/>
-              </a:rPr>
-              <a:t>3. 微信、WhatsApp、二维码、电话、表单都已经统一。</a:t>
+              <a:rPr sz="1200">
+                <a:solidFill>
+                  <a:srgbClr val="102033"/>
+                </a:solidFill>
+                <a:latin typeface="Microsoft YaHei"/>
+              </a:rPr>
+              <a:t>来源页面、课程方向、年级/年龄</a:t>
             </a:r>
           </a:p>
           <a:p>
             <a:pPr>
               <a:spcAft>
-                <a:spcPts val="1400"/>
+                <a:spcPts val="700"/>
               </a:spcAft>
             </a:pPr>
             <a:r>
-              <a:rPr sz="1500" b="0">
-                <a:solidFill>
-                  <a:srgbClr val="FFFFFF"/>
-                </a:solidFill>
-                <a:latin typeface="Microsoft YaHei"/>
-              </a:rPr>
-              <a:t>4. 后续最重要的是补老师真实资料、家长真实评价和真实新闻。</a:t>
-            </a:r>
-          </a:p>
+              <a:rPr sz="1200">
+                <a:solidFill>
+                  <a:srgbClr val="102033"/>
+                </a:solidFill>
+                <a:latin typeface="Microsoft YaHei"/>
+              </a:rPr>
+              <a:t>需求摘要、当前状态、是否试听、是否报名、备注</a:t>
+            </a:r>
+          </a:p>
+        </p:txBody>
+      </p:sp>
+      <p:sp>
+        <p:nvSpPr>
+          <p:cNvPr id="10" name="Rounded Rectangle 9"/>
+          <p:cNvSpPr/>
+          <p:nvPr/>
+        </p:nvSpPr>
+        <p:spPr>
+          <a:xfrm>
+            <a:off x="4526280" y="1828800"/>
+            <a:ext cx="3749039" cy="2331720"/>
+          </a:xfrm>
+          <a:prstGeom prst="roundRect">
+            <a:avLst/>
+          </a:prstGeom>
+          <a:solidFill>
+            <a:srgbClr val="FFFFFF"/>
+          </a:solidFill>
+          <a:ln>
+            <a:solidFill>
+              <a:srgbClr val="DCE3EB"/>
+            </a:solidFill>
+          </a:ln>
+        </p:spPr>
+        <p:style>
+          <a:lnRef idx="1">
+            <a:schemeClr val="accent1"/>
+          </a:lnRef>
+          <a:fillRef idx="3">
+            <a:schemeClr val="accent1"/>
+          </a:fillRef>
+          <a:effectRef idx="2">
+            <a:schemeClr val="accent1"/>
+          </a:effectRef>
+          <a:fontRef idx="minor">
+            <a:schemeClr val="lt1"/>
+          </a:fontRef>
+        </p:style>
+        <p:txBody>
+          <a:bodyPr rtlCol="0" anchor="ctr"/>
+          <a:lstStyle/>
+          <a:p>
+            <a:pPr algn="ctr"/>
+          </a:p>
+        </p:txBody>
+      </p:sp>
+      <p:sp>
+        <p:nvSpPr>
+          <p:cNvPr id="11" name="Rectangle 10"/>
+          <p:cNvSpPr/>
+          <p:nvPr/>
+        </p:nvSpPr>
+        <p:spPr>
+          <a:xfrm>
+            <a:off x="4526280" y="1828800"/>
+            <a:ext cx="109728" cy="2331720"/>
+          </a:xfrm>
+          <a:prstGeom prst="rect">
+            <a:avLst/>
+          </a:prstGeom>
+          <a:solidFill>
+            <a:srgbClr val="22A35C"/>
+          </a:solidFill>
+          <a:ln>
+            <a:noFill/>
+          </a:ln>
+        </p:spPr>
+        <p:style>
+          <a:lnRef idx="1">
+            <a:schemeClr val="accent1"/>
+          </a:lnRef>
+          <a:fillRef idx="3">
+            <a:schemeClr val="accent1"/>
+          </a:fillRef>
+          <a:effectRef idx="2">
+            <a:schemeClr val="accent1"/>
+          </a:effectRef>
+          <a:fontRef idx="minor">
+            <a:schemeClr val="lt1"/>
+          </a:fontRef>
+        </p:style>
+        <p:txBody>
+          <a:bodyPr rtlCol="0" anchor="ctr"/>
+          <a:lstStyle/>
+          <a:p>
+            <a:pPr algn="ctr"/>
+          </a:p>
+        </p:txBody>
+      </p:sp>
+      <p:sp>
+        <p:nvSpPr>
+          <p:cNvPr id="12" name="TextBox 11"/>
+          <p:cNvSpPr txBox="1"/>
+          <p:nvPr/>
+        </p:nvSpPr>
+        <p:spPr>
+          <a:xfrm>
+            <a:off x="4754880" y="1993392"/>
+            <a:ext cx="3383279" cy="2057400"/>
+          </a:xfrm>
+          <a:prstGeom prst="rect">
+            <a:avLst/>
+          </a:prstGeom>
+          <a:noFill/>
+        </p:spPr>
+        <p:txBody>
+          <a:bodyPr wrap="square">
+            <a:spAutoFit/>
+          </a:bodyPr>
+          <a:lstStyle/>
           <a:p>
             <a:pPr>
               <a:spcAft>
-                <a:spcPts val="1400"/>
+                <a:spcPts val="400"/>
               </a:spcAft>
             </a:pPr>
             <a:r>
-              <a:rPr sz="1500" b="0">
-                <a:solidFill>
-                  <a:srgbClr val="FFFFFF"/>
-                </a:solidFill>
-                <a:latin typeface="Microsoft YaHei"/>
-              </a:rPr>
-              <a:t>5. 完成后即可进入最终上线前检查与部署。</a:t>
-            </a:r>
-          </a:p>
-        </p:txBody>
-      </p:sp>
-      <p:sp>
-        <p:nvSpPr>
-          <p:cNvPr id="7" name="TextBox 6"/>
+              <a:rPr sz="1500" b="1">
+                <a:solidFill>
+                  <a:srgbClr val="102033"/>
+                </a:solidFill>
+                <a:latin typeface="Microsoft YaHei"/>
+              </a:rPr>
+              <a:t>微信里直接记</a:t>
+            </a:r>
+          </a:p>
+          <a:p>
+            <a:pPr>
+              <a:spcBef>
+                <a:spcPts val="400"/>
+              </a:spcBef>
+            </a:pPr>
+            <a:r>
+              <a:rPr sz="1100">
+                <a:solidFill>
+                  <a:srgbClr val="5A6B7F"/>
+                </a:solidFill>
+                <a:latin typeface="Microsoft YaHei"/>
+              </a:rPr>
+              <a:t>时间：
+昵称：
+微信号：
+来源：
+课程：
+年级：
+需求：
+状态：
+试听：
+报名：
+备注：</a:t>
+            </a:r>
+          </a:p>
+        </p:txBody>
+      </p:sp>
+      <p:sp>
+        <p:nvSpPr>
+          <p:cNvPr id="13" name="Rounded Rectangle 12"/>
+          <p:cNvSpPr/>
+          <p:nvPr/>
+        </p:nvSpPr>
+        <p:spPr>
+          <a:xfrm>
+            <a:off x="8458200" y="1828800"/>
+            <a:ext cx="3154680" cy="2331720"/>
+          </a:xfrm>
+          <a:prstGeom prst="roundRect">
+            <a:avLst/>
+          </a:prstGeom>
+          <a:solidFill>
+            <a:srgbClr val="FFFFFF"/>
+          </a:solidFill>
+          <a:ln>
+            <a:solidFill>
+              <a:srgbClr val="DCE3EB"/>
+            </a:solidFill>
+          </a:ln>
+        </p:spPr>
+        <p:style>
+          <a:lnRef idx="1">
+            <a:schemeClr val="accent1"/>
+          </a:lnRef>
+          <a:fillRef idx="3">
+            <a:schemeClr val="accent1"/>
+          </a:fillRef>
+          <a:effectRef idx="2">
+            <a:schemeClr val="accent1"/>
+          </a:effectRef>
+          <a:fontRef idx="minor">
+            <a:schemeClr val="lt1"/>
+          </a:fontRef>
+        </p:style>
+        <p:txBody>
+          <a:bodyPr rtlCol="0" anchor="ctr"/>
+          <a:lstStyle/>
+          <a:p>
+            <a:pPr algn="ctr"/>
+          </a:p>
+        </p:txBody>
+      </p:sp>
+      <p:sp>
+        <p:nvSpPr>
+          <p:cNvPr id="14" name="Rectangle 13"/>
+          <p:cNvSpPr/>
+          <p:nvPr/>
+        </p:nvSpPr>
+        <p:spPr>
+          <a:xfrm>
+            <a:off x="8458200" y="1828800"/>
+            <a:ext cx="109728" cy="2331720"/>
+          </a:xfrm>
+          <a:prstGeom prst="rect">
+            <a:avLst/>
+          </a:prstGeom>
+          <a:solidFill>
+            <a:srgbClr val="F59E0B"/>
+          </a:solidFill>
+          <a:ln>
+            <a:noFill/>
+          </a:ln>
+        </p:spPr>
+        <p:style>
+          <a:lnRef idx="1">
+            <a:schemeClr val="accent1"/>
+          </a:lnRef>
+          <a:fillRef idx="3">
+            <a:schemeClr val="accent1"/>
+          </a:fillRef>
+          <a:effectRef idx="2">
+            <a:schemeClr val="accent1"/>
+          </a:effectRef>
+          <a:fontRef idx="minor">
+            <a:schemeClr val="lt1"/>
+          </a:fontRef>
+        </p:style>
+        <p:txBody>
+          <a:bodyPr rtlCol="0" anchor="ctr"/>
+          <a:lstStyle/>
+          <a:p>
+            <a:pPr algn="ctr"/>
+          </a:p>
+        </p:txBody>
+      </p:sp>
+      <p:sp>
+        <p:nvSpPr>
+          <p:cNvPr id="15" name="TextBox 14"/>
           <p:cNvSpPr txBox="1"/>
           <p:nvPr/>
         </p:nvSpPr>
         <p:spPr>
           <a:xfrm>
-            <a:off x="822960" y="6126480"/>
-            <a:ext cx="10515600" cy="365760"/>
+            <a:off x="8686800" y="1993392"/>
+            <a:ext cx="2788920" cy="2057400"/>
           </a:xfrm>
           <a:prstGeom prst="rect">
             <a:avLst/>
@@ -10554,20 +11233,468 @@
           <a:noFill/>
         </p:spPr>
         <p:txBody>
-          <a:bodyPr wrap="none">
+          <a:bodyPr wrap="square">
             <a:spAutoFit/>
           </a:bodyPr>
           <a:lstStyle/>
           <a:p>
-            <a:pPr algn="r"/>
+            <a:pPr>
+              <a:spcAft>
+                <a:spcPts val="400"/>
+              </a:spcAft>
+            </a:pPr>
+            <a:r>
+              <a:rPr sz="1400" b="1">
+                <a:solidFill>
+                  <a:srgbClr val="102033"/>
+                </a:solidFill>
+                <a:latin typeface="Microsoft YaHei"/>
+              </a:rPr>
+              <a:t>一行版示例</a:t>
+            </a:r>
+          </a:p>
+          <a:p>
+            <a:pPr>
+              <a:spcBef>
+                <a:spcPts val="400"/>
+              </a:spcBef>
+            </a:pPr>
             <a:r>
               <a:rPr sz="1100">
                 <a:solidFill>
-                  <a:srgbClr val="CDD6E0"/>
-                </a:solidFill>
-                <a:latin typeface="Microsoft YaHei"/>
-              </a:rPr>
-              <a:t>IvyEuro Education · 网站改造分析报告</a:t>
+                  <a:srgbClr val="5A6B7F"/>
+                </a:solidFill>
+                <a:latin typeface="Microsoft YaHei"/>
+              </a:rPr>
+              <a:t>2026-06-02 10:30 | IvyEuro学校刘老师 | sophialiu0826 | 首页 | 中文 | 5年级 | 想试听阅读写作 | 已回复 | 是 | 否 | 周末方便</a:t>
+            </a:r>
+          </a:p>
+        </p:txBody>
+      </p:sp>
+      <p:sp>
+        <p:nvSpPr>
+          <p:cNvPr id="16" name="Rounded Rectangle 15"/>
+          <p:cNvSpPr/>
+          <p:nvPr/>
+        </p:nvSpPr>
+        <p:spPr>
+          <a:xfrm>
+            <a:off x="594360" y="4480560"/>
+            <a:ext cx="5440680" cy="1600200"/>
+          </a:xfrm>
+          <a:prstGeom prst="roundRect">
+            <a:avLst/>
+          </a:prstGeom>
+          <a:solidFill>
+            <a:srgbClr val="FFFFFF"/>
+          </a:solidFill>
+          <a:ln>
+            <a:solidFill>
+              <a:srgbClr val="DCE3EB"/>
+            </a:solidFill>
+          </a:ln>
+        </p:spPr>
+        <p:style>
+          <a:lnRef idx="1">
+            <a:schemeClr val="accent1"/>
+          </a:lnRef>
+          <a:fillRef idx="3">
+            <a:schemeClr val="accent1"/>
+          </a:fillRef>
+          <a:effectRef idx="2">
+            <a:schemeClr val="accent1"/>
+          </a:effectRef>
+          <a:fontRef idx="minor">
+            <a:schemeClr val="lt1"/>
+          </a:fontRef>
+        </p:style>
+        <p:txBody>
+          <a:bodyPr rtlCol="0" anchor="ctr"/>
+          <a:lstStyle/>
+          <a:p>
+            <a:pPr algn="ctr"/>
+          </a:p>
+        </p:txBody>
+      </p:sp>
+      <p:sp>
+        <p:nvSpPr>
+          <p:cNvPr id="17" name="Rectangle 16"/>
+          <p:cNvSpPr/>
+          <p:nvPr/>
+        </p:nvSpPr>
+        <p:spPr>
+          <a:xfrm>
+            <a:off x="594360" y="4480560"/>
+            <a:ext cx="109728" cy="1600200"/>
+          </a:xfrm>
+          <a:prstGeom prst="rect">
+            <a:avLst/>
+          </a:prstGeom>
+          <a:solidFill>
+            <a:srgbClr val="19C4B0"/>
+          </a:solidFill>
+          <a:ln>
+            <a:noFill/>
+          </a:ln>
+        </p:spPr>
+        <p:style>
+          <a:lnRef idx="1">
+            <a:schemeClr val="accent1"/>
+          </a:lnRef>
+          <a:fillRef idx="3">
+            <a:schemeClr val="accent1"/>
+          </a:fillRef>
+          <a:effectRef idx="2">
+            <a:schemeClr val="accent1"/>
+          </a:effectRef>
+          <a:fontRef idx="minor">
+            <a:schemeClr val="lt1"/>
+          </a:fontRef>
+        </p:style>
+        <p:txBody>
+          <a:bodyPr rtlCol="0" anchor="ctr"/>
+          <a:lstStyle/>
+          <a:p>
+            <a:pPr algn="ctr"/>
+          </a:p>
+        </p:txBody>
+      </p:sp>
+      <p:sp>
+        <p:nvSpPr>
+          <p:cNvPr id="18" name="TextBox 17"/>
+          <p:cNvSpPr txBox="1"/>
+          <p:nvPr/>
+        </p:nvSpPr>
+        <p:spPr>
+          <a:xfrm>
+            <a:off x="822960" y="4645152"/>
+            <a:ext cx="5074920" cy="1325880"/>
+          </a:xfrm>
+          <a:prstGeom prst="rect">
+            <a:avLst/>
+          </a:prstGeom>
+          <a:noFill/>
+        </p:spPr>
+        <p:txBody>
+          <a:bodyPr wrap="square">
+            <a:spAutoFit/>
+          </a:bodyPr>
+          <a:lstStyle/>
+          <a:p>
+            <a:pPr>
+              <a:spcAft>
+                <a:spcPts val="400"/>
+              </a:spcAft>
+            </a:pPr>
+            <a:r>
+              <a:rPr sz="1500" b="1">
+                <a:solidFill>
+                  <a:srgbClr val="102033"/>
+                </a:solidFill>
+                <a:latin typeface="Microsoft YaHei"/>
+              </a:rPr>
+              <a:t>建议状态标签</a:t>
+            </a:r>
+          </a:p>
+          <a:p>
+            <a:pPr>
+              <a:spcBef>
+                <a:spcPts val="400"/>
+              </a:spcBef>
+            </a:pPr>
+            <a:r>
+              <a:rPr sz="1100">
+                <a:solidFill>
+                  <a:srgbClr val="5A6B7F"/>
+                </a:solidFill>
+                <a:latin typeface="Microsoft YaHei"/>
+              </a:rPr>
+              <a:t/>
+            </a:r>
+          </a:p>
+        </p:txBody>
+      </p:sp>
+      <p:sp>
+        <p:nvSpPr>
+          <p:cNvPr id="19" name="TextBox 18"/>
+          <p:cNvSpPr txBox="1"/>
+          <p:nvPr/>
+        </p:nvSpPr>
+        <p:spPr>
+          <a:xfrm>
+            <a:off x="822960" y="5047488"/>
+            <a:ext cx="5029200" cy="914400"/>
+          </a:xfrm>
+          <a:prstGeom prst="rect">
+            <a:avLst/>
+          </a:prstGeom>
+          <a:noFill/>
+        </p:spPr>
+        <p:txBody>
+          <a:bodyPr wrap="square">
+            <a:normAutofit/>
+          </a:bodyPr>
+          <a:lstStyle/>
+          <a:p>
+            <a:pPr>
+              <a:spcAft>
+                <a:spcPts val="700"/>
+              </a:spcAft>
+            </a:pPr>
+            <a:r>
+              <a:rPr sz="1200">
+                <a:solidFill>
+                  <a:srgbClr val="102033"/>
+                </a:solidFill>
+                <a:latin typeface="Microsoft YaHei"/>
+              </a:rPr>
+              <a:t>新咨询</a:t>
+            </a:r>
+          </a:p>
+          <a:p>
+            <a:pPr>
+              <a:spcAft>
+                <a:spcPts val="700"/>
+              </a:spcAft>
+            </a:pPr>
+            <a:r>
+              <a:rPr sz="1200">
+                <a:solidFill>
+                  <a:srgbClr val="102033"/>
+                </a:solidFill>
+                <a:latin typeface="Microsoft YaHei"/>
+              </a:rPr>
+              <a:t>已回复</a:t>
+            </a:r>
+          </a:p>
+          <a:p>
+            <a:pPr>
+              <a:spcAft>
+                <a:spcPts val="700"/>
+              </a:spcAft>
+            </a:pPr>
+            <a:r>
+              <a:rPr sz="1200">
+                <a:solidFill>
+                  <a:srgbClr val="102033"/>
+                </a:solidFill>
+                <a:latin typeface="Microsoft YaHei"/>
+              </a:rPr>
+              <a:t>已预约</a:t>
+            </a:r>
+          </a:p>
+          <a:p>
+            <a:pPr>
+              <a:spcAft>
+                <a:spcPts val="700"/>
+              </a:spcAft>
+            </a:pPr>
+            <a:r>
+              <a:rPr sz="1200">
+                <a:solidFill>
+                  <a:srgbClr val="102033"/>
+                </a:solidFill>
+                <a:latin typeface="Microsoft YaHei"/>
+              </a:rPr>
+              <a:t>已报名</a:t>
+            </a:r>
+          </a:p>
+        </p:txBody>
+      </p:sp>
+      <p:sp>
+        <p:nvSpPr>
+          <p:cNvPr id="20" name="Rounded Rectangle 19"/>
+          <p:cNvSpPr/>
+          <p:nvPr/>
+        </p:nvSpPr>
+        <p:spPr>
+          <a:xfrm>
+            <a:off x="6309360" y="4480560"/>
+            <a:ext cx="5212080" cy="1600200"/>
+          </a:xfrm>
+          <a:prstGeom prst="roundRect">
+            <a:avLst/>
+          </a:prstGeom>
+          <a:solidFill>
+            <a:srgbClr val="FFFFFF"/>
+          </a:solidFill>
+          <a:ln>
+            <a:solidFill>
+              <a:srgbClr val="DCE3EB"/>
+            </a:solidFill>
+          </a:ln>
+        </p:spPr>
+        <p:style>
+          <a:lnRef idx="1">
+            <a:schemeClr val="accent1"/>
+          </a:lnRef>
+          <a:fillRef idx="3">
+            <a:schemeClr val="accent1"/>
+          </a:fillRef>
+          <a:effectRef idx="2">
+            <a:schemeClr val="accent1"/>
+          </a:effectRef>
+          <a:fontRef idx="minor">
+            <a:schemeClr val="lt1"/>
+          </a:fontRef>
+        </p:style>
+        <p:txBody>
+          <a:bodyPr rtlCol="0" anchor="ctr"/>
+          <a:lstStyle/>
+          <a:p>
+            <a:pPr algn="ctr"/>
+          </a:p>
+        </p:txBody>
+      </p:sp>
+      <p:sp>
+        <p:nvSpPr>
+          <p:cNvPr id="21" name="Rectangle 20"/>
+          <p:cNvSpPr/>
+          <p:nvPr/>
+        </p:nvSpPr>
+        <p:spPr>
+          <a:xfrm>
+            <a:off x="6309360" y="4480560"/>
+            <a:ext cx="109728" cy="1600200"/>
+          </a:xfrm>
+          <a:prstGeom prst="rect">
+            <a:avLst/>
+          </a:prstGeom>
+          <a:solidFill>
+            <a:srgbClr val="22A35C"/>
+          </a:solidFill>
+          <a:ln>
+            <a:noFill/>
+          </a:ln>
+        </p:spPr>
+        <p:style>
+          <a:lnRef idx="1">
+            <a:schemeClr val="accent1"/>
+          </a:lnRef>
+          <a:fillRef idx="3">
+            <a:schemeClr val="accent1"/>
+          </a:fillRef>
+          <a:effectRef idx="2">
+            <a:schemeClr val="accent1"/>
+          </a:effectRef>
+          <a:fontRef idx="minor">
+            <a:schemeClr val="lt1"/>
+          </a:fontRef>
+        </p:style>
+        <p:txBody>
+          <a:bodyPr rtlCol="0" anchor="ctr"/>
+          <a:lstStyle/>
+          <a:p>
+            <a:pPr algn="ctr"/>
+          </a:p>
+        </p:txBody>
+      </p:sp>
+      <p:sp>
+        <p:nvSpPr>
+          <p:cNvPr id="22" name="TextBox 21"/>
+          <p:cNvSpPr txBox="1"/>
+          <p:nvPr/>
+        </p:nvSpPr>
+        <p:spPr>
+          <a:xfrm>
+            <a:off x="6537960" y="4645152"/>
+            <a:ext cx="4846320" cy="1325880"/>
+          </a:xfrm>
+          <a:prstGeom prst="rect">
+            <a:avLst/>
+          </a:prstGeom>
+          <a:noFill/>
+        </p:spPr>
+        <p:txBody>
+          <a:bodyPr wrap="square">
+            <a:spAutoFit/>
+          </a:bodyPr>
+          <a:lstStyle/>
+          <a:p>
+            <a:pPr>
+              <a:spcAft>
+                <a:spcPts val="400"/>
+              </a:spcAft>
+            </a:pPr>
+            <a:r>
+              <a:rPr sz="1500" b="1">
+                <a:solidFill>
+                  <a:srgbClr val="102033"/>
+                </a:solidFill>
+                <a:latin typeface="Microsoft YaHei"/>
+              </a:rPr>
+              <a:t>建议固定标签</a:t>
+            </a:r>
+          </a:p>
+          <a:p>
+            <a:pPr>
+              <a:spcBef>
+                <a:spcPts val="400"/>
+              </a:spcBef>
+            </a:pPr>
+            <a:r>
+              <a:rPr sz="1100">
+                <a:solidFill>
+                  <a:srgbClr val="5A6B7F"/>
+                </a:solidFill>
+                <a:latin typeface="Microsoft YaHei"/>
+              </a:rPr>
+              <a:t/>
+            </a:r>
+          </a:p>
+        </p:txBody>
+      </p:sp>
+      <p:sp>
+        <p:nvSpPr>
+          <p:cNvPr id="23" name="TextBox 22"/>
+          <p:cNvSpPr txBox="1"/>
+          <p:nvPr/>
+        </p:nvSpPr>
+        <p:spPr>
+          <a:xfrm>
+            <a:off x="6537960" y="5047488"/>
+            <a:ext cx="4800600" cy="914400"/>
+          </a:xfrm>
+          <a:prstGeom prst="rect">
+            <a:avLst/>
+          </a:prstGeom>
+          <a:noFill/>
+        </p:spPr>
+        <p:txBody>
+          <a:bodyPr wrap="square">
+            <a:normAutofit/>
+          </a:bodyPr>
+          <a:lstStyle/>
+          <a:p>
+            <a:pPr>
+              <a:spcAft>
+                <a:spcPts val="700"/>
+              </a:spcAft>
+            </a:pPr>
+            <a:r>
+              <a:rPr sz="1200">
+                <a:solidFill>
+                  <a:srgbClr val="102033"/>
+                </a:solidFill>
+                <a:latin typeface="Microsoft YaHei"/>
+              </a:rPr>
+              <a:t>英语 / 数学 / 中文 / 西语/加泰</a:t>
+            </a:r>
+          </a:p>
+          <a:p>
+            <a:pPr>
+              <a:spcAft>
+                <a:spcPts val="700"/>
+              </a:spcAft>
+            </a:pPr>
+            <a:r>
+              <a:rPr sz="1200">
+                <a:solidFill>
+                  <a:srgbClr val="102033"/>
+                </a:solidFill>
+                <a:latin typeface="Microsoft YaHei"/>
+              </a:rPr>
+              <a:t>试听 / 报名</a:t>
             </a:r>
           </a:p>
         </p:txBody>

</xml_diff>

<commit_message>
Add WeChat extraction workflow slide
</commit_message>
<xml_diff>
--- a/IvyEuro_Education_网站改造分析报告.pptx
+++ b/IvyEuro_Education_网站改造分析报告.pptx
@@ -15,6 +15,7 @@
     <p:sldId id="263" r:id="rId14"/>
     <p:sldId id="264" r:id="rId15"/>
     <p:sldId id="265" r:id="rId16"/>
+    <p:sldId id="266" r:id="rId17"/>
   </p:sldIdLst>
   <p:sldSz cx="12191695" cy="6858000" type="screen4x3"/>
   <p:notesSz cx="6858000" cy="9144000"/>
@@ -3529,6 +3530,1107 @@
 </file>
 
 <file path=ppt/slides/slide10.xml><?xml version="1.0" encoding="utf-8"?>
+<p:sld xmlns:a="http://schemas.openxmlformats.org/drawingml/2006/main" xmlns:p="http://schemas.openxmlformats.org/presentationml/2006/main" xmlns:r="http://schemas.openxmlformats.org/officeDocument/2006/relationships">
+  <p:cSld>
+    <p:bg>
+      <p:bgPr>
+        <a:solidFill>
+          <a:srgbClr val="FFFFFF"/>
+        </a:solidFill>
+        <a:effectLst/>
+      </p:bgPr>
+    </p:bg>
+    <p:spTree>
+      <p:nvGrpSpPr>
+        <p:cNvPr id="1" name=""/>
+        <p:cNvGrpSpPr/>
+        <p:nvPr/>
+      </p:nvGrpSpPr>
+      <p:grpSpPr/>
+      <p:sp>
+        <p:nvSpPr>
+          <p:cNvPr id="2" name="Rectangle 1"/>
+          <p:cNvSpPr/>
+          <p:nvPr/>
+        </p:nvSpPr>
+        <p:spPr>
+          <a:xfrm>
+            <a:off x="0" y="0"/>
+            <a:ext cx="12191695" cy="841248"/>
+          </a:xfrm>
+          <a:prstGeom prst="rect">
+            <a:avLst/>
+          </a:prstGeom>
+          <a:solidFill>
+            <a:srgbClr val="0B1220"/>
+          </a:solidFill>
+          <a:ln>
+            <a:noFill/>
+          </a:ln>
+        </p:spPr>
+        <p:style>
+          <a:lnRef idx="1">
+            <a:schemeClr val="accent1"/>
+          </a:lnRef>
+          <a:fillRef idx="3">
+            <a:schemeClr val="accent1"/>
+          </a:fillRef>
+          <a:effectRef idx="2">
+            <a:schemeClr val="accent1"/>
+          </a:effectRef>
+          <a:fontRef idx="minor">
+            <a:schemeClr val="lt1"/>
+          </a:fontRef>
+        </p:style>
+        <p:txBody>
+          <a:bodyPr rtlCol="0" anchor="ctr"/>
+          <a:lstStyle/>
+          <a:p>
+            <a:pPr algn="ctr"/>
+          </a:p>
+        </p:txBody>
+      </p:sp>
+      <p:sp>
+        <p:nvSpPr>
+          <p:cNvPr id="3" name="TextBox 2"/>
+          <p:cNvSpPr txBox="1"/>
+          <p:nvPr/>
+        </p:nvSpPr>
+        <p:spPr>
+          <a:xfrm>
+            <a:off x="502920" y="164592"/>
+            <a:ext cx="9692640" cy="384048"/>
+          </a:xfrm>
+          <a:prstGeom prst="rect">
+            <a:avLst/>
+          </a:prstGeom>
+          <a:noFill/>
+        </p:spPr>
+        <p:txBody>
+          <a:bodyPr wrap="none">
+            <a:spAutoFit/>
+          </a:bodyPr>
+          <a:lstStyle/>
+          <a:p>
+            <a:r>
+              <a:rPr sz="2000" b="1">
+                <a:solidFill>
+                  <a:srgbClr val="FFFFFF"/>
+                </a:solidFill>
+                <a:latin typeface="Microsoft YaHei"/>
+              </a:rPr>
+              <a:t>微信自动抽取方案</a:t>
+            </a:r>
+          </a:p>
+        </p:txBody>
+      </p:sp>
+      <p:sp>
+        <p:nvSpPr>
+          <p:cNvPr id="4" name="TextBox 3"/>
+          <p:cNvSpPr txBox="1"/>
+          <p:nvPr/>
+        </p:nvSpPr>
+        <p:spPr>
+          <a:xfrm>
+            <a:off x="8412480" y="182880"/>
+            <a:ext cx="3291840" cy="310896"/>
+          </a:xfrm>
+          <a:prstGeom prst="rect">
+            <a:avLst/>
+          </a:prstGeom>
+          <a:noFill/>
+        </p:spPr>
+        <p:txBody>
+          <a:bodyPr wrap="none">
+            <a:spAutoFit/>
+          </a:bodyPr>
+          <a:lstStyle/>
+          <a:p>
+            <a:pPr algn="r"/>
+            <a:r>
+              <a:rPr sz="1050">
+                <a:solidFill>
+                  <a:srgbClr val="CCD6E0"/>
+                </a:solidFill>
+                <a:latin typeface="Microsoft YaHei"/>
+              </a:rPr>
+              <a:t>模板 + 标签 + 结构化记录</a:t>
+            </a:r>
+          </a:p>
+        </p:txBody>
+      </p:sp>
+      <p:sp>
+        <p:nvSpPr>
+          <p:cNvPr id="5" name="TextBox 4"/>
+          <p:cNvSpPr txBox="1"/>
+          <p:nvPr/>
+        </p:nvSpPr>
+        <p:spPr>
+          <a:xfrm>
+            <a:off x="594360" y="1051560"/>
+            <a:ext cx="10789920" cy="1280160"/>
+          </a:xfrm>
+          <a:prstGeom prst="rect">
+            <a:avLst/>
+          </a:prstGeom>
+          <a:noFill/>
+        </p:spPr>
+        <p:txBody>
+          <a:bodyPr wrap="square">
+            <a:spAutoFit/>
+          </a:bodyPr>
+          <a:lstStyle/>
+          <a:p>
+            <a:r>
+              <a:rPr sz="2800" b="1">
+                <a:solidFill>
+                  <a:srgbClr val="102033"/>
+                </a:solidFill>
+                <a:latin typeface="Microsoft YaHei"/>
+              </a:rPr>
+              <a:t>从聊天变成表格</a:t>
+            </a:r>
+          </a:p>
+          <a:p>
+            <a:pPr>
+              <a:spcBef>
+                <a:spcPts val="1000"/>
+              </a:spcBef>
+            </a:pPr>
+            <a:r>
+              <a:rPr sz="1250">
+                <a:solidFill>
+                  <a:srgbClr val="5A6B7F"/>
+                </a:solidFill>
+                <a:latin typeface="Microsoft YaHei"/>
+              </a:rPr>
+              <a:t>把非结构化微信消息自动变成可统计的咨询记录。</a:t>
+            </a:r>
+          </a:p>
+        </p:txBody>
+      </p:sp>
+      <p:sp>
+        <p:nvSpPr>
+          <p:cNvPr id="6" name="Rounded Rectangle 5"/>
+          <p:cNvSpPr/>
+          <p:nvPr/>
+        </p:nvSpPr>
+        <p:spPr>
+          <a:xfrm>
+            <a:off x="594360" y="1828800"/>
+            <a:ext cx="3794760" cy="2331720"/>
+          </a:xfrm>
+          <a:prstGeom prst="roundRect">
+            <a:avLst/>
+          </a:prstGeom>
+          <a:solidFill>
+            <a:srgbClr val="FFFFFF"/>
+          </a:solidFill>
+          <a:ln>
+            <a:solidFill>
+              <a:srgbClr val="DCE3EB"/>
+            </a:solidFill>
+          </a:ln>
+        </p:spPr>
+        <p:style>
+          <a:lnRef idx="1">
+            <a:schemeClr val="accent1"/>
+          </a:lnRef>
+          <a:fillRef idx="3">
+            <a:schemeClr val="accent1"/>
+          </a:fillRef>
+          <a:effectRef idx="2">
+            <a:schemeClr val="accent1"/>
+          </a:effectRef>
+          <a:fontRef idx="minor">
+            <a:schemeClr val="lt1"/>
+          </a:fontRef>
+        </p:style>
+        <p:txBody>
+          <a:bodyPr rtlCol="0" anchor="ctr"/>
+          <a:lstStyle/>
+          <a:p>
+            <a:pPr algn="ctr"/>
+          </a:p>
+        </p:txBody>
+      </p:sp>
+      <p:sp>
+        <p:nvSpPr>
+          <p:cNvPr id="7" name="Rectangle 6"/>
+          <p:cNvSpPr/>
+          <p:nvPr/>
+        </p:nvSpPr>
+        <p:spPr>
+          <a:xfrm>
+            <a:off x="594360" y="1828800"/>
+            <a:ext cx="109728" cy="2331720"/>
+          </a:xfrm>
+          <a:prstGeom prst="rect">
+            <a:avLst/>
+          </a:prstGeom>
+          <a:solidFill>
+            <a:srgbClr val="1B6DFF"/>
+          </a:solidFill>
+          <a:ln>
+            <a:noFill/>
+          </a:ln>
+        </p:spPr>
+        <p:style>
+          <a:lnRef idx="1">
+            <a:schemeClr val="accent1"/>
+          </a:lnRef>
+          <a:fillRef idx="3">
+            <a:schemeClr val="accent1"/>
+          </a:fillRef>
+          <a:effectRef idx="2">
+            <a:schemeClr val="accent1"/>
+          </a:effectRef>
+          <a:fontRef idx="minor">
+            <a:schemeClr val="lt1"/>
+          </a:fontRef>
+        </p:style>
+        <p:txBody>
+          <a:bodyPr rtlCol="0" anchor="ctr"/>
+          <a:lstStyle/>
+          <a:p>
+            <a:pPr algn="ctr"/>
+          </a:p>
+        </p:txBody>
+      </p:sp>
+      <p:sp>
+        <p:nvSpPr>
+          <p:cNvPr id="8" name="TextBox 7"/>
+          <p:cNvSpPr txBox="1"/>
+          <p:nvPr/>
+        </p:nvSpPr>
+        <p:spPr>
+          <a:xfrm>
+            <a:off x="822960" y="1993392"/>
+            <a:ext cx="3429000" cy="2057400"/>
+          </a:xfrm>
+          <a:prstGeom prst="rect">
+            <a:avLst/>
+          </a:prstGeom>
+          <a:noFill/>
+        </p:spPr>
+        <p:txBody>
+          <a:bodyPr wrap="square">
+            <a:spAutoFit/>
+          </a:bodyPr>
+          <a:lstStyle/>
+          <a:p>
+            <a:pPr>
+              <a:spcAft>
+                <a:spcPts val="400"/>
+              </a:spcAft>
+            </a:pPr>
+            <a:r>
+              <a:rPr sz="1500" b="1">
+                <a:solidFill>
+                  <a:srgbClr val="102033"/>
+                </a:solidFill>
+                <a:latin typeface="Microsoft YaHei"/>
+              </a:rPr>
+              <a:t>获取聊天内容</a:t>
+            </a:r>
+          </a:p>
+          <a:p>
+            <a:pPr>
+              <a:spcBef>
+                <a:spcPts val="400"/>
+              </a:spcBef>
+            </a:pPr>
+            <a:r>
+              <a:rPr sz="1100">
+                <a:solidFill>
+                  <a:srgbClr val="5A6B7F"/>
+                </a:solidFill>
+                <a:latin typeface="Microsoft YaHei"/>
+              </a:rPr>
+              <a:t/>
+            </a:r>
+          </a:p>
+        </p:txBody>
+      </p:sp>
+      <p:sp>
+        <p:nvSpPr>
+          <p:cNvPr id="9" name="TextBox 8"/>
+          <p:cNvSpPr txBox="1"/>
+          <p:nvPr/>
+        </p:nvSpPr>
+        <p:spPr>
+          <a:xfrm>
+            <a:off x="822960" y="2395728"/>
+            <a:ext cx="3383280" cy="1645919"/>
+          </a:xfrm>
+          <a:prstGeom prst="rect">
+            <a:avLst/>
+          </a:prstGeom>
+          <a:noFill/>
+        </p:spPr>
+        <p:txBody>
+          <a:bodyPr wrap="square">
+            <a:normAutofit/>
+          </a:bodyPr>
+          <a:lstStyle/>
+          <a:p>
+            <a:pPr>
+              <a:spcAft>
+                <a:spcPts val="700"/>
+              </a:spcAft>
+            </a:pPr>
+            <a:r>
+              <a:rPr sz="1200">
+                <a:solidFill>
+                  <a:srgbClr val="102033"/>
+                </a:solidFill>
+                <a:latin typeface="Microsoft YaHei"/>
+              </a:rPr>
+              <a:t>企业微信 / 客服系统：可接官方 API</a:t>
+            </a:r>
+          </a:p>
+          <a:p>
+            <a:pPr>
+              <a:spcAft>
+                <a:spcPts val="700"/>
+              </a:spcAft>
+            </a:pPr>
+            <a:r>
+              <a:rPr sz="1200">
+                <a:solidFill>
+                  <a:srgbClr val="102033"/>
+                </a:solidFill>
+                <a:latin typeface="Microsoft YaHei"/>
+              </a:rPr>
+              <a:t>个人微信：建议人工导出后再解析</a:t>
+            </a:r>
+          </a:p>
+          <a:p>
+            <a:pPr>
+              <a:spcAft>
+                <a:spcPts val="700"/>
+              </a:spcAft>
+            </a:pPr>
+            <a:r>
+              <a:rPr sz="1200">
+                <a:solidFill>
+                  <a:srgbClr val="102033"/>
+                </a:solidFill>
+                <a:latin typeface="Microsoft YaHei"/>
+              </a:rPr>
+              <a:t>优先处理“摘要”，少保留原文</a:t>
+            </a:r>
+          </a:p>
+        </p:txBody>
+      </p:sp>
+      <p:sp>
+        <p:nvSpPr>
+          <p:cNvPr id="10" name="Rounded Rectangle 9"/>
+          <p:cNvSpPr/>
+          <p:nvPr/>
+        </p:nvSpPr>
+        <p:spPr>
+          <a:xfrm>
+            <a:off x="4526280" y="1828800"/>
+            <a:ext cx="3794760" cy="2331720"/>
+          </a:xfrm>
+          <a:prstGeom prst="roundRect">
+            <a:avLst/>
+          </a:prstGeom>
+          <a:solidFill>
+            <a:srgbClr val="FFFFFF"/>
+          </a:solidFill>
+          <a:ln>
+            <a:solidFill>
+              <a:srgbClr val="DCE3EB"/>
+            </a:solidFill>
+          </a:ln>
+        </p:spPr>
+        <p:style>
+          <a:lnRef idx="1">
+            <a:schemeClr val="accent1"/>
+          </a:lnRef>
+          <a:fillRef idx="3">
+            <a:schemeClr val="accent1"/>
+          </a:fillRef>
+          <a:effectRef idx="2">
+            <a:schemeClr val="accent1"/>
+          </a:effectRef>
+          <a:fontRef idx="minor">
+            <a:schemeClr val="lt1"/>
+          </a:fontRef>
+        </p:style>
+        <p:txBody>
+          <a:bodyPr rtlCol="0" anchor="ctr"/>
+          <a:lstStyle/>
+          <a:p>
+            <a:pPr algn="ctr"/>
+          </a:p>
+        </p:txBody>
+      </p:sp>
+      <p:sp>
+        <p:nvSpPr>
+          <p:cNvPr id="11" name="Rectangle 10"/>
+          <p:cNvSpPr/>
+          <p:nvPr/>
+        </p:nvSpPr>
+        <p:spPr>
+          <a:xfrm>
+            <a:off x="4526280" y="1828800"/>
+            <a:ext cx="109728" cy="2331720"/>
+          </a:xfrm>
+          <a:prstGeom prst="rect">
+            <a:avLst/>
+          </a:prstGeom>
+          <a:solidFill>
+            <a:srgbClr val="22A35C"/>
+          </a:solidFill>
+          <a:ln>
+            <a:noFill/>
+          </a:ln>
+        </p:spPr>
+        <p:style>
+          <a:lnRef idx="1">
+            <a:schemeClr val="accent1"/>
+          </a:lnRef>
+          <a:fillRef idx="3">
+            <a:schemeClr val="accent1"/>
+          </a:fillRef>
+          <a:effectRef idx="2">
+            <a:schemeClr val="accent1"/>
+          </a:effectRef>
+          <a:fontRef idx="minor">
+            <a:schemeClr val="lt1"/>
+          </a:fontRef>
+        </p:style>
+        <p:txBody>
+          <a:bodyPr rtlCol="0" anchor="ctr"/>
+          <a:lstStyle/>
+          <a:p>
+            <a:pPr algn="ctr"/>
+          </a:p>
+        </p:txBody>
+      </p:sp>
+      <p:sp>
+        <p:nvSpPr>
+          <p:cNvPr id="12" name="TextBox 11"/>
+          <p:cNvSpPr txBox="1"/>
+          <p:nvPr/>
+        </p:nvSpPr>
+        <p:spPr>
+          <a:xfrm>
+            <a:off x="4754880" y="1993392"/>
+            <a:ext cx="3429000" cy="2057400"/>
+          </a:xfrm>
+          <a:prstGeom prst="rect">
+            <a:avLst/>
+          </a:prstGeom>
+          <a:noFill/>
+        </p:spPr>
+        <p:txBody>
+          <a:bodyPr wrap="square">
+            <a:spAutoFit/>
+          </a:bodyPr>
+          <a:lstStyle/>
+          <a:p>
+            <a:pPr>
+              <a:spcAft>
+                <a:spcPts val="400"/>
+              </a:spcAft>
+            </a:pPr>
+            <a:r>
+              <a:rPr sz="1500" b="1">
+                <a:solidFill>
+                  <a:srgbClr val="102033"/>
+                </a:solidFill>
+                <a:latin typeface="Microsoft YaHei"/>
+              </a:rPr>
+              <a:t>抽取关键字段</a:t>
+            </a:r>
+          </a:p>
+          <a:p>
+            <a:pPr>
+              <a:spcBef>
+                <a:spcPts val="400"/>
+              </a:spcBef>
+            </a:pPr>
+            <a:r>
+              <a:rPr sz="1100">
+                <a:solidFill>
+                  <a:srgbClr val="5A6B7F"/>
+                </a:solidFill>
+                <a:latin typeface="Microsoft YaHei"/>
+              </a:rPr>
+              <a:t/>
+            </a:r>
+          </a:p>
+        </p:txBody>
+      </p:sp>
+      <p:sp>
+        <p:nvSpPr>
+          <p:cNvPr id="13" name="TextBox 12"/>
+          <p:cNvSpPr txBox="1"/>
+          <p:nvPr/>
+        </p:nvSpPr>
+        <p:spPr>
+          <a:xfrm>
+            <a:off x="4754880" y="2395728"/>
+            <a:ext cx="3383280" cy="1645919"/>
+          </a:xfrm>
+          <a:prstGeom prst="rect">
+            <a:avLst/>
+          </a:prstGeom>
+          <a:noFill/>
+        </p:spPr>
+        <p:txBody>
+          <a:bodyPr wrap="square">
+            <a:normAutofit/>
+          </a:bodyPr>
+          <a:lstStyle/>
+          <a:p>
+            <a:pPr>
+              <a:spcAft>
+                <a:spcPts val="700"/>
+              </a:spcAft>
+            </a:pPr>
+            <a:r>
+              <a:rPr sz="1200">
+                <a:solidFill>
+                  <a:srgbClr val="102033"/>
+                </a:solidFill>
+                <a:latin typeface="Microsoft YaHei"/>
+              </a:rPr>
+              <a:t>课程方向、年级、意向程度</a:t>
+            </a:r>
+          </a:p>
+          <a:p>
+            <a:pPr>
+              <a:spcAft>
+                <a:spcPts val="700"/>
+              </a:spcAft>
+            </a:pPr>
+            <a:r>
+              <a:rPr sz="1200">
+                <a:solidFill>
+                  <a:srgbClr val="102033"/>
+                </a:solidFill>
+                <a:latin typeface="Microsoft YaHei"/>
+              </a:rPr>
+              <a:t>是否问价格 / 试听 / 时间</a:t>
+            </a:r>
+          </a:p>
+          <a:p>
+            <a:pPr>
+              <a:spcAft>
+                <a:spcPts val="700"/>
+              </a:spcAft>
+            </a:pPr>
+            <a:r>
+              <a:rPr sz="1200">
+                <a:solidFill>
+                  <a:srgbClr val="102033"/>
+                </a:solidFill>
+                <a:latin typeface="Microsoft YaHei"/>
+              </a:rPr>
+              <a:t>联系方式、来源、状态标签</a:t>
+            </a:r>
+          </a:p>
+        </p:txBody>
+      </p:sp>
+      <p:sp>
+        <p:nvSpPr>
+          <p:cNvPr id="14" name="Rounded Rectangle 13"/>
+          <p:cNvSpPr/>
+          <p:nvPr/>
+        </p:nvSpPr>
+        <p:spPr>
+          <a:xfrm>
+            <a:off x="8458200" y="1828800"/>
+            <a:ext cx="3154680" cy="2331720"/>
+          </a:xfrm>
+          <a:prstGeom prst="roundRect">
+            <a:avLst/>
+          </a:prstGeom>
+          <a:solidFill>
+            <a:srgbClr val="FFFFFF"/>
+          </a:solidFill>
+          <a:ln>
+            <a:solidFill>
+              <a:srgbClr val="DCE3EB"/>
+            </a:solidFill>
+          </a:ln>
+        </p:spPr>
+        <p:style>
+          <a:lnRef idx="1">
+            <a:schemeClr val="accent1"/>
+          </a:lnRef>
+          <a:fillRef idx="3">
+            <a:schemeClr val="accent1"/>
+          </a:fillRef>
+          <a:effectRef idx="2">
+            <a:schemeClr val="accent1"/>
+          </a:effectRef>
+          <a:fontRef idx="minor">
+            <a:schemeClr val="lt1"/>
+          </a:fontRef>
+        </p:style>
+        <p:txBody>
+          <a:bodyPr rtlCol="0" anchor="ctr"/>
+          <a:lstStyle/>
+          <a:p>
+            <a:pPr algn="ctr"/>
+          </a:p>
+        </p:txBody>
+      </p:sp>
+      <p:sp>
+        <p:nvSpPr>
+          <p:cNvPr id="15" name="Rectangle 14"/>
+          <p:cNvSpPr/>
+          <p:nvPr/>
+        </p:nvSpPr>
+        <p:spPr>
+          <a:xfrm>
+            <a:off x="8458200" y="1828800"/>
+            <a:ext cx="109728" cy="2331720"/>
+          </a:xfrm>
+          <a:prstGeom prst="rect">
+            <a:avLst/>
+          </a:prstGeom>
+          <a:solidFill>
+            <a:srgbClr val="F59E0B"/>
+          </a:solidFill>
+          <a:ln>
+            <a:noFill/>
+          </a:ln>
+        </p:spPr>
+        <p:style>
+          <a:lnRef idx="1">
+            <a:schemeClr val="accent1"/>
+          </a:lnRef>
+          <a:fillRef idx="3">
+            <a:schemeClr val="accent1"/>
+          </a:fillRef>
+          <a:effectRef idx="2">
+            <a:schemeClr val="accent1"/>
+          </a:effectRef>
+          <a:fontRef idx="minor">
+            <a:schemeClr val="lt1"/>
+          </a:fontRef>
+        </p:style>
+        <p:txBody>
+          <a:bodyPr rtlCol="0" anchor="ctr"/>
+          <a:lstStyle/>
+          <a:p>
+            <a:pPr algn="ctr"/>
+          </a:p>
+        </p:txBody>
+      </p:sp>
+      <p:sp>
+        <p:nvSpPr>
+          <p:cNvPr id="16" name="TextBox 15"/>
+          <p:cNvSpPr txBox="1"/>
+          <p:nvPr/>
+        </p:nvSpPr>
+        <p:spPr>
+          <a:xfrm>
+            <a:off x="8686800" y="1993392"/>
+            <a:ext cx="2788920" cy="2057400"/>
+          </a:xfrm>
+          <a:prstGeom prst="rect">
+            <a:avLst/>
+          </a:prstGeom>
+          <a:noFill/>
+        </p:spPr>
+        <p:txBody>
+          <a:bodyPr wrap="square">
+            <a:spAutoFit/>
+          </a:bodyPr>
+          <a:lstStyle/>
+          <a:p>
+            <a:pPr>
+              <a:spcAft>
+                <a:spcPts val="400"/>
+              </a:spcAft>
+            </a:pPr>
+            <a:r>
+              <a:rPr sz="1500" b="1">
+                <a:solidFill>
+                  <a:srgbClr val="102033"/>
+                </a:solidFill>
+                <a:latin typeface="Microsoft YaHei"/>
+              </a:rPr>
+              <a:t>落地输出</a:t>
+            </a:r>
+          </a:p>
+          <a:p>
+            <a:pPr>
+              <a:spcBef>
+                <a:spcPts val="400"/>
+              </a:spcBef>
+            </a:pPr>
+            <a:r>
+              <a:rPr sz="1100">
+                <a:solidFill>
+                  <a:srgbClr val="5A6B7F"/>
+                </a:solidFill>
+                <a:latin typeface="Microsoft YaHei"/>
+              </a:rPr>
+              <a:t/>
+            </a:r>
+          </a:p>
+        </p:txBody>
+      </p:sp>
+      <p:sp>
+        <p:nvSpPr>
+          <p:cNvPr id="17" name="TextBox 16"/>
+          <p:cNvSpPr txBox="1"/>
+          <p:nvPr/>
+        </p:nvSpPr>
+        <p:spPr>
+          <a:xfrm>
+            <a:off x="8686800" y="2395728"/>
+            <a:ext cx="2743200" cy="1645919"/>
+          </a:xfrm>
+          <a:prstGeom prst="rect">
+            <a:avLst/>
+          </a:prstGeom>
+          <a:noFill/>
+        </p:spPr>
+        <p:txBody>
+          <a:bodyPr wrap="square">
+            <a:normAutofit/>
+          </a:bodyPr>
+          <a:lstStyle/>
+          <a:p>
+            <a:pPr>
+              <a:spcAft>
+                <a:spcPts val="700"/>
+              </a:spcAft>
+            </a:pPr>
+            <a:r>
+              <a:rPr sz="1200">
+                <a:solidFill>
+                  <a:srgbClr val="102033"/>
+                </a:solidFill>
+                <a:latin typeface="Microsoft YaHei"/>
+              </a:rPr>
+              <a:t>一行结构化记录</a:t>
+            </a:r>
+          </a:p>
+          <a:p>
+            <a:pPr>
+              <a:spcAft>
+                <a:spcPts val="700"/>
+              </a:spcAft>
+            </a:pPr>
+            <a:r>
+              <a:rPr sz="1200">
+                <a:solidFill>
+                  <a:srgbClr val="102033"/>
+                </a:solidFill>
+                <a:latin typeface="Microsoft YaHei"/>
+              </a:rPr>
+              <a:t>Excel / Sheet / CRM</a:t>
+            </a:r>
+          </a:p>
+        </p:txBody>
+      </p:sp>
+      <p:sp>
+        <p:nvSpPr>
+          <p:cNvPr id="18" name="Rounded Rectangle 17"/>
+          <p:cNvSpPr/>
+          <p:nvPr/>
+        </p:nvSpPr>
+        <p:spPr>
+          <a:xfrm>
+            <a:off x="594360" y="4480560"/>
+            <a:ext cx="5440680" cy="1463040"/>
+          </a:xfrm>
+          <a:prstGeom prst="roundRect">
+            <a:avLst/>
+          </a:prstGeom>
+          <a:solidFill>
+            <a:srgbClr val="FFFFFF"/>
+          </a:solidFill>
+          <a:ln>
+            <a:solidFill>
+              <a:srgbClr val="DCE3EB"/>
+            </a:solidFill>
+          </a:ln>
+        </p:spPr>
+        <p:style>
+          <a:lnRef idx="1">
+            <a:schemeClr val="accent1"/>
+          </a:lnRef>
+          <a:fillRef idx="3">
+            <a:schemeClr val="accent1"/>
+          </a:fillRef>
+          <a:effectRef idx="2">
+            <a:schemeClr val="accent1"/>
+          </a:effectRef>
+          <a:fontRef idx="minor">
+            <a:schemeClr val="lt1"/>
+          </a:fontRef>
+        </p:style>
+        <p:txBody>
+          <a:bodyPr rtlCol="0" anchor="ctr"/>
+          <a:lstStyle/>
+          <a:p>
+            <a:pPr algn="ctr"/>
+          </a:p>
+        </p:txBody>
+      </p:sp>
+      <p:sp>
+        <p:nvSpPr>
+          <p:cNvPr id="19" name="Rectangle 18"/>
+          <p:cNvSpPr/>
+          <p:nvPr/>
+        </p:nvSpPr>
+        <p:spPr>
+          <a:xfrm>
+            <a:off x="594360" y="4480560"/>
+            <a:ext cx="109728" cy="1463040"/>
+          </a:xfrm>
+          <a:prstGeom prst="rect">
+            <a:avLst/>
+          </a:prstGeom>
+          <a:solidFill>
+            <a:srgbClr val="19C4B0"/>
+          </a:solidFill>
+          <a:ln>
+            <a:noFill/>
+          </a:ln>
+        </p:spPr>
+        <p:style>
+          <a:lnRef idx="1">
+            <a:schemeClr val="accent1"/>
+          </a:lnRef>
+          <a:fillRef idx="3">
+            <a:schemeClr val="accent1"/>
+          </a:fillRef>
+          <a:effectRef idx="2">
+            <a:schemeClr val="accent1"/>
+          </a:effectRef>
+          <a:fontRef idx="minor">
+            <a:schemeClr val="lt1"/>
+          </a:fontRef>
+        </p:style>
+        <p:txBody>
+          <a:bodyPr rtlCol="0" anchor="ctr"/>
+          <a:lstStyle/>
+          <a:p>
+            <a:pPr algn="ctr"/>
+          </a:p>
+        </p:txBody>
+      </p:sp>
+      <p:sp>
+        <p:nvSpPr>
+          <p:cNvPr id="20" name="TextBox 19"/>
+          <p:cNvSpPr txBox="1"/>
+          <p:nvPr/>
+        </p:nvSpPr>
+        <p:spPr>
+          <a:xfrm>
+            <a:off x="822960" y="4645152"/>
+            <a:ext cx="5074920" cy="1188720"/>
+          </a:xfrm>
+          <a:prstGeom prst="rect">
+            <a:avLst/>
+          </a:prstGeom>
+          <a:noFill/>
+        </p:spPr>
+        <p:txBody>
+          <a:bodyPr wrap="square">
+            <a:spAutoFit/>
+          </a:bodyPr>
+          <a:lstStyle/>
+          <a:p>
+            <a:pPr>
+              <a:spcAft>
+                <a:spcPts val="400"/>
+              </a:spcAft>
+            </a:pPr>
+            <a:r>
+              <a:rPr sz="1500" b="1">
+                <a:solidFill>
+                  <a:srgbClr val="102033"/>
+                </a:solidFill>
+                <a:latin typeface="Microsoft YaHei"/>
+              </a:rPr>
+              <a:t>实现方式</a:t>
+            </a:r>
+          </a:p>
+          <a:p>
+            <a:pPr>
+              <a:spcBef>
+                <a:spcPts val="400"/>
+              </a:spcBef>
+            </a:pPr>
+            <a:r>
+              <a:rPr sz="1100">
+                <a:solidFill>
+                  <a:srgbClr val="5A6B7F"/>
+                </a:solidFill>
+                <a:latin typeface="Microsoft YaHei"/>
+              </a:rPr>
+              <a:t>轻量版：正则 + 关键词 + 表格
+进阶版：大模型 API 返回 JSON 模板</a:t>
+            </a:r>
+          </a:p>
+        </p:txBody>
+      </p:sp>
+      <p:sp>
+        <p:nvSpPr>
+          <p:cNvPr id="21" name="Rounded Rectangle 20"/>
+          <p:cNvSpPr/>
+          <p:nvPr/>
+        </p:nvSpPr>
+        <p:spPr>
+          <a:xfrm>
+            <a:off x="6309360" y="4480560"/>
+            <a:ext cx="5212080" cy="1463040"/>
+          </a:xfrm>
+          <a:prstGeom prst="roundRect">
+            <a:avLst/>
+          </a:prstGeom>
+          <a:solidFill>
+            <a:srgbClr val="FFFFFF"/>
+          </a:solidFill>
+          <a:ln>
+            <a:solidFill>
+              <a:srgbClr val="DCE3EB"/>
+            </a:solidFill>
+          </a:ln>
+        </p:spPr>
+        <p:style>
+          <a:lnRef idx="1">
+            <a:schemeClr val="accent1"/>
+          </a:lnRef>
+          <a:fillRef idx="3">
+            <a:schemeClr val="accent1"/>
+          </a:fillRef>
+          <a:effectRef idx="2">
+            <a:schemeClr val="accent1"/>
+          </a:effectRef>
+          <a:fontRef idx="minor">
+            <a:schemeClr val="lt1"/>
+          </a:fontRef>
+        </p:style>
+        <p:txBody>
+          <a:bodyPr rtlCol="0" anchor="ctr"/>
+          <a:lstStyle/>
+          <a:p>
+            <a:pPr algn="ctr"/>
+          </a:p>
+        </p:txBody>
+      </p:sp>
+      <p:sp>
+        <p:nvSpPr>
+          <p:cNvPr id="22" name="Rectangle 21"/>
+          <p:cNvSpPr/>
+          <p:nvPr/>
+        </p:nvSpPr>
+        <p:spPr>
+          <a:xfrm>
+            <a:off x="6309360" y="4480560"/>
+            <a:ext cx="109728" cy="1463040"/>
+          </a:xfrm>
+          <a:prstGeom prst="rect">
+            <a:avLst/>
+          </a:prstGeom>
+          <a:solidFill>
+            <a:srgbClr val="EF4444"/>
+          </a:solidFill>
+          <a:ln>
+            <a:noFill/>
+          </a:ln>
+        </p:spPr>
+        <p:style>
+          <a:lnRef idx="1">
+            <a:schemeClr val="accent1"/>
+          </a:lnRef>
+          <a:fillRef idx="3">
+            <a:schemeClr val="accent1"/>
+          </a:fillRef>
+          <a:effectRef idx="2">
+            <a:schemeClr val="accent1"/>
+          </a:effectRef>
+          <a:fontRef idx="minor">
+            <a:schemeClr val="lt1"/>
+          </a:fontRef>
+        </p:style>
+        <p:txBody>
+          <a:bodyPr rtlCol="0" anchor="ctr"/>
+          <a:lstStyle/>
+          <a:p>
+            <a:pPr algn="ctr"/>
+          </a:p>
+        </p:txBody>
+      </p:sp>
+      <p:sp>
+        <p:nvSpPr>
+          <p:cNvPr id="23" name="TextBox 22"/>
+          <p:cNvSpPr txBox="1"/>
+          <p:nvPr/>
+        </p:nvSpPr>
+        <p:spPr>
+          <a:xfrm>
+            <a:off x="6537960" y="4645152"/>
+            <a:ext cx="4846320" cy="1188720"/>
+          </a:xfrm>
+          <a:prstGeom prst="rect">
+            <a:avLst/>
+          </a:prstGeom>
+          <a:noFill/>
+        </p:spPr>
+        <p:txBody>
+          <a:bodyPr wrap="square">
+            <a:spAutoFit/>
+          </a:bodyPr>
+          <a:lstStyle/>
+          <a:p>
+            <a:pPr>
+              <a:spcAft>
+                <a:spcPts val="400"/>
+              </a:spcAft>
+            </a:pPr>
+            <a:r>
+              <a:rPr sz="1500" b="1">
+                <a:solidFill>
+                  <a:srgbClr val="102033"/>
+                </a:solidFill>
+                <a:latin typeface="Microsoft YaHei"/>
+              </a:rPr>
+              <a:t>注意事项</a:t>
+            </a:r>
+          </a:p>
+          <a:p>
+            <a:pPr>
+              <a:spcBef>
+                <a:spcPts val="400"/>
+              </a:spcBef>
+            </a:pPr>
+            <a:r>
+              <a:rPr sz="1100">
+                <a:solidFill>
+                  <a:srgbClr val="5A6B7F"/>
+                </a:solidFill>
+                <a:latin typeface="Microsoft YaHei"/>
+              </a:rPr>
+              <a:t>个人微信建议半自动人工确认；企业微信/客服系统更适合全流程接入。</a:t>
+            </a:r>
+          </a:p>
+        </p:txBody>
+      </p:sp>
+    </p:spTree>
+  </p:cSld>
+  <p:clrMapOvr>
+    <a:masterClrMapping/>
+  </p:clrMapOvr>
+</p:sld>
+</file>
+
+<file path=ppt/slides/slide11.xml><?xml version="1.0" encoding="utf-8"?>
 <p:sld xmlns:a="http://schemas.openxmlformats.org/drawingml/2006/main" xmlns:p="http://schemas.openxmlformats.org/presentationml/2006/main" xmlns:r="http://schemas.openxmlformats.org/officeDocument/2006/relationships">
   <p:cSld>
     <p:bg>

</xml_diff>